<commit_message>
Add prototype photos and operating directions.
Co-authored-by: Cursor <cursoragent@cursor.com>
</commit_message>
<xml_diff>
--- a/air-pressure-cannon-presentation.pptx
+++ b/air-pressure-cannon-presentation.pptx
@@ -19,6 +19,8 @@
     <p:sldId id="267" r:id="rId18"/>
     <p:sldId id="268" r:id="rId19"/>
     <p:sldId id="269" r:id="rId20"/>
+    <p:sldId id="270" r:id="rId21"/>
+    <p:sldId id="271" r:id="rId22"/>
   </p:sldIdLst>
   <p:sldSz cx="12191695" cy="6858000" type="screen4x3"/>
   <p:notesSz cx="6858000" cy="9144000"/>
@@ -3161,7 +3163,7 @@
         <p:spPr>
           <a:xfrm>
             <a:off x="640080" y="502920"/>
-            <a:ext cx="2011680" cy="320040"/>
+            <a:ext cx="2103120" cy="274320"/>
           </a:xfrm>
           <a:prstGeom prst="rect">
             <a:avLst/>
@@ -3179,6 +3181,7 @@
                 <a:solidFill>
                   <a:srgbClr val="D89B3D"/>
                 </a:solidFill>
+                <a:latin typeface="Trebuchet MS"/>
               </a:defRPr>
             </a:pPr>
             <a:r>
@@ -3195,8 +3198,8 @@
         </p:nvSpPr>
         <p:spPr>
           <a:xfrm>
-            <a:off x="640080" y="868680"/>
-            <a:ext cx="10881360" cy="1143000"/>
+            <a:off x="640080" y="841248"/>
+            <a:ext cx="10881360" cy="868680"/>
           </a:xfrm>
           <a:prstGeom prst="rect">
             <a:avLst/>
@@ -3210,7 +3213,7 @@
           <a:lstStyle/>
           <a:p>
             <a:pPr>
-              <a:defRPr sz="4400" b="1">
+              <a:defRPr sz="4200" b="1">
                 <a:solidFill>
                   <a:srgbClr val="F2F0E8"/>
                 </a:solidFill>
@@ -3231,8 +3234,8 @@
         </p:nvSpPr>
         <p:spPr>
           <a:xfrm>
-            <a:off x="640080" y="2240280"/>
-            <a:ext cx="10881360" cy="3886200"/>
+            <a:off x="640080" y="1965960"/>
+            <a:ext cx="5577840" cy="4297680"/>
           </a:xfrm>
           <a:prstGeom prst="roundRect">
             <a:avLst/>
@@ -3276,8 +3279,8 @@
         </p:nvSpPr>
         <p:spPr>
           <a:xfrm>
-            <a:off x="960120" y="2487168"/>
-            <a:ext cx="10241280" cy="3429000"/>
+            <a:off x="960120" y="2240280"/>
+            <a:ext cx="4983480" cy="3703320"/>
           </a:xfrm>
           <a:prstGeom prst="rect">
             <a:avLst/>
@@ -3292,9 +3295,9 @@
           <a:p>
             <a:pPr>
               <a:spcAft>
-                <a:spcPts val="800"/>
+                <a:spcPts val="600"/>
               </a:spcAft>
-              <a:defRPr sz="2200">
+              <a:defRPr sz="2000">
                 <a:solidFill>
                   <a:srgbClr val="F2F0E8"/>
                 </a:solidFill>
@@ -3307,9 +3310,9 @@
           <a:p>
             <a:pPr>
               <a:spcAft>
-                <a:spcPts val="800"/>
+                <a:spcPts val="600"/>
               </a:spcAft>
-              <a:defRPr sz="2200">
+              <a:defRPr sz="2000">
                 <a:solidFill>
                   <a:srgbClr val="B8C4B8"/>
                 </a:solidFill>
@@ -3322,9 +3325,9 @@
           <a:p>
             <a:pPr>
               <a:spcAft>
-                <a:spcPts val="800"/>
+                <a:spcPts val="600"/>
               </a:spcAft>
-              <a:defRPr sz="2200">
+              <a:defRPr sz="2000">
                 <a:solidFill>
                   <a:srgbClr val="B8C4B8"/>
                 </a:solidFill>
@@ -3337,9 +3340,9 @@
           <a:p>
             <a:pPr>
               <a:spcAft>
-                <a:spcPts val="800"/>
+                <a:spcPts val="600"/>
               </a:spcAft>
-              <a:defRPr sz="2200">
+              <a:defRPr sz="2000">
                 <a:solidFill>
                   <a:srgbClr val="B8C4B8"/>
                 </a:solidFill>
@@ -3351,16 +3354,83 @@
           </a:p>
         </p:txBody>
       </p:sp>
-      <p:sp>
-        <p:nvSpPr>
-          <p:cNvPr id="7" name="TextBox 6"/>
+      <p:pic>
+        <p:nvPicPr>
+          <p:cNvPr id="7" name="Picture 6" descr="prototype-standing.jpg"/>
+          <p:cNvPicPr>
+            <a:picLocks noChangeAspect="1"/>
+          </p:cNvPicPr>
+          <p:nvPr/>
+        </p:nvPicPr>
+        <p:blipFill>
+          <a:blip r:embed="rId2"/>
+          <a:stretch>
+            <a:fillRect/>
+          </a:stretch>
+        </p:blipFill>
+        <p:spPr>
+          <a:xfrm>
+            <a:off x="6446520" y="1965960"/>
+            <a:ext cx="5120640" cy="4297680"/>
+          </a:xfrm>
+          <a:prstGeom prst="rect">
+            <a:avLst/>
+          </a:prstGeom>
+        </p:spPr>
+      </p:pic>
+      <p:sp>
+        <p:nvSpPr>
+          <p:cNvPr id="8" name="Rectangle 7"/>
+          <p:cNvSpPr/>
+          <p:nvPr/>
+        </p:nvSpPr>
+        <p:spPr>
+          <a:xfrm>
+            <a:off x="6446520" y="1965960"/>
+            <a:ext cx="5120640" cy="4297680"/>
+          </a:xfrm>
+          <a:prstGeom prst="rect">
+            <a:avLst/>
+          </a:prstGeom>
+          <a:noFill/>
+          <a:ln w="12700">
+            <a:solidFill>
+              <a:srgbClr val="365144"/>
+            </a:solidFill>
+          </a:ln>
+        </p:spPr>
+        <p:style>
+          <a:lnRef idx="1">
+            <a:schemeClr val="accent1"/>
+          </a:lnRef>
+          <a:fillRef idx="3">
+            <a:schemeClr val="accent1"/>
+          </a:fillRef>
+          <a:effectRef idx="2">
+            <a:schemeClr val="accent1"/>
+          </a:effectRef>
+          <a:fontRef idx="minor">
+            <a:schemeClr val="lt1"/>
+          </a:fontRef>
+        </p:style>
+        <p:txBody>
+          <a:bodyPr rtlCol="0" anchor="ctr"/>
+          <a:lstStyle/>
+          <a:p>
+            <a:pPr algn="ctr"/>
+          </a:p>
+        </p:txBody>
+      </p:sp>
+      <p:sp>
+        <p:nvSpPr>
+          <p:cNvPr id="9" name="TextBox 8"/>
           <p:cNvSpPr txBox="1"/>
           <p:nvPr/>
         </p:nvSpPr>
         <p:spPr>
           <a:xfrm>
-            <a:off x="640080" y="6355080"/>
-            <a:ext cx="10881360" cy="274320"/>
+            <a:off x="640080" y="6382512"/>
+            <a:ext cx="10881360" cy="228600"/>
           </a:xfrm>
           <a:prstGeom prst="rect">
             <a:avLst/>
@@ -3374,10 +3444,11 @@
           <a:lstStyle/>
           <a:p>
             <a:pPr algn="ctr">
-              <a:defRPr sz="1000">
+              <a:defRPr sz="1000" b="0">
                 <a:solidFill>
                   <a:srgbClr val="B8C4B8"/>
                 </a:solidFill>
+                <a:latin typeface="Trebuchet MS"/>
               </a:defRPr>
             </a:pPr>
             <a:r>
@@ -3464,7 +3535,7 @@
         <p:spPr>
           <a:xfrm>
             <a:off x="640080" y="502920"/>
-            <a:ext cx="2011680" cy="320040"/>
+            <a:ext cx="2103120" cy="274320"/>
           </a:xfrm>
           <a:prstGeom prst="rect">
             <a:avLst/>
@@ -3482,6 +3553,7 @@
                 <a:solidFill>
                   <a:srgbClr val="D89B3D"/>
                 </a:solidFill>
+                <a:latin typeface="Trebuchet MS"/>
               </a:defRPr>
             </a:pPr>
             <a:r>
@@ -3498,8 +3570,8 @@
         </p:nvSpPr>
         <p:spPr>
           <a:xfrm>
-            <a:off x="640080" y="868680"/>
-            <a:ext cx="10881360" cy="1143000"/>
+            <a:off x="640080" y="841248"/>
+            <a:ext cx="10881360" cy="868680"/>
           </a:xfrm>
           <a:prstGeom prst="rect">
             <a:avLst/>
@@ -3513,7 +3585,7 @@
           <a:lstStyle/>
           <a:p>
             <a:pPr>
-              <a:defRPr sz="3800" b="1">
+              <a:defRPr sz="3400" b="1">
                 <a:solidFill>
                   <a:srgbClr val="F2F0E8"/>
                 </a:solidFill>
@@ -3521,7 +3593,7 @@
               </a:defRPr>
             </a:pPr>
             <a:r>
-              <a:t>Build Procedure</a:t>
+              <a:t>Release Handle</a:t>
             </a:r>
           </a:p>
         </p:txBody>
@@ -3534,8 +3606,8 @@
         </p:nvSpPr>
         <p:spPr>
           <a:xfrm>
-            <a:off x="640080" y="2240280"/>
-            <a:ext cx="10881360" cy="3886200"/>
+            <a:off x="640080" y="1965960"/>
+            <a:ext cx="5577840" cy="4297680"/>
           </a:xfrm>
           <a:prstGeom prst="roundRect">
             <a:avLst/>
@@ -3579,8 +3651,8 @@
         </p:nvSpPr>
         <p:spPr>
           <a:xfrm>
-            <a:off x="960120" y="2487168"/>
-            <a:ext cx="10241280" cy="3429000"/>
+            <a:off x="960120" y="2240280"/>
+            <a:ext cx="4983480" cy="3703320"/>
           </a:xfrm>
           <a:prstGeom prst="rect">
             <a:avLst/>
@@ -3595,105 +3667,127 @@
           <a:p>
             <a:pPr>
               <a:spcAft>
-                <a:spcPts val="800"/>
+                <a:spcPts val="600"/>
               </a:spcAft>
-              <a:defRPr sz="1800">
+              <a:defRPr sz="2000">
                 <a:solidFill>
                   <a:srgbClr val="F2F0E8"/>
                 </a:solidFill>
               </a:defRPr>
             </a:pPr>
             <a:r>
-              <a:t>• Define requirements.</a:t>
+              <a:t>• Handle gives the operator a simple control point.</a:t>
             </a:r>
           </a:p>
           <a:p>
             <a:pPr>
               <a:spcAft>
-                <a:spcPts val="800"/>
+                <a:spcPts val="600"/>
               </a:spcAft>
-              <a:defRPr sz="1800">
+              <a:defRPr sz="2000">
                 <a:solidFill>
                   <a:srgbClr val="B8C4B8"/>
                 </a:solidFill>
               </a:defRPr>
             </a:pPr>
             <a:r>
-              <a:t>• Build low-pressure air path.</a:t>
+              <a:t>• Control is placed away from the launch opening.</a:t>
             </a:r>
           </a:p>
           <a:p>
             <a:pPr>
               <a:spcAft>
-                <a:spcPts val="800"/>
+                <a:spcPts val="600"/>
               </a:spcAft>
-              <a:defRPr sz="1800">
+              <a:defRPr sz="2000">
                 <a:solidFill>
                   <a:srgbClr val="B8C4B8"/>
                 </a:solidFill>
               </a:defRPr>
             </a:pPr>
             <a:r>
-              <a:t>• Add gauge and fill/release controls.</a:t>
-            </a:r>
-          </a:p>
-          <a:p>
-            <a:pPr>
-              <a:spcAft>
-                <a:spcPts val="800"/>
-              </a:spcAft>
-              <a:defRPr sz="1800">
-                <a:solidFill>
-                  <a:srgbClr val="B8C4B8"/>
-                </a:solidFill>
-              </a:defRPr>
-            </a:pPr>
-            <a:r>
-              <a:t>• Build support frame.</a:t>
-            </a:r>
-          </a:p>
-          <a:p>
-            <a:pPr>
-              <a:spcAft>
-                <a:spcPts val="800"/>
-              </a:spcAft>
-              <a:defRPr sz="1800">
-                <a:solidFill>
-                  <a:srgbClr val="B8C4B8"/>
-                </a:solidFill>
-              </a:defRPr>
-            </a:pPr>
-            <a:r>
-              <a:t>• Add labels and operating steps.</a:t>
-            </a:r>
-          </a:p>
-          <a:p>
-            <a:pPr>
-              <a:spcAft>
-                <a:spcPts val="800"/>
-              </a:spcAft>
-              <a:defRPr sz="1800">
-                <a:solidFill>
-                  <a:srgbClr val="B8C4B8"/>
-                </a:solidFill>
-              </a:defRPr>
-            </a:pPr>
-            <a:r>
-              <a:t>• Test range, reload time, and usability.</a:t>
-            </a:r>
-          </a:p>
-        </p:txBody>
-      </p:sp>
-      <p:sp>
-        <p:nvSpPr>
-          <p:cNvPr id="7" name="TextBox 6"/>
+              <a:t>• A clear handle makes the firing step easier to teach.</a:t>
+            </a:r>
+          </a:p>
+        </p:txBody>
+      </p:sp>
+      <p:pic>
+        <p:nvPicPr>
+          <p:cNvPr id="7" name="Picture 6" descr="trigger-handle.jpg"/>
+          <p:cNvPicPr>
+            <a:picLocks noChangeAspect="1"/>
+          </p:cNvPicPr>
+          <p:nvPr/>
+        </p:nvPicPr>
+        <p:blipFill>
+          <a:blip r:embed="rId2"/>
+          <a:stretch>
+            <a:fillRect/>
+          </a:stretch>
+        </p:blipFill>
+        <p:spPr>
+          <a:xfrm>
+            <a:off x="6446520" y="2194560"/>
+            <a:ext cx="5120640" cy="3840480"/>
+          </a:xfrm>
+          <a:prstGeom prst="rect">
+            <a:avLst/>
+          </a:prstGeom>
+        </p:spPr>
+      </p:pic>
+      <p:sp>
+        <p:nvSpPr>
+          <p:cNvPr id="8" name="Rectangle 7"/>
+          <p:cNvSpPr/>
+          <p:nvPr/>
+        </p:nvSpPr>
+        <p:spPr>
+          <a:xfrm>
+            <a:off x="6446520" y="1965960"/>
+            <a:ext cx="5120640" cy="4297680"/>
+          </a:xfrm>
+          <a:prstGeom prst="rect">
+            <a:avLst/>
+          </a:prstGeom>
+          <a:noFill/>
+          <a:ln w="12700">
+            <a:solidFill>
+              <a:srgbClr val="365144"/>
+            </a:solidFill>
+          </a:ln>
+        </p:spPr>
+        <p:style>
+          <a:lnRef idx="1">
+            <a:schemeClr val="accent1"/>
+          </a:lnRef>
+          <a:fillRef idx="3">
+            <a:schemeClr val="accent1"/>
+          </a:fillRef>
+          <a:effectRef idx="2">
+            <a:schemeClr val="accent1"/>
+          </a:effectRef>
+          <a:fontRef idx="minor">
+            <a:schemeClr val="lt1"/>
+          </a:fontRef>
+        </p:style>
+        <p:txBody>
+          <a:bodyPr rtlCol="0" anchor="ctr"/>
+          <a:lstStyle/>
+          <a:p>
+            <a:pPr algn="ctr"/>
+          </a:p>
+        </p:txBody>
+      </p:sp>
+      <p:sp>
+        <p:nvSpPr>
+          <p:cNvPr id="9" name="TextBox 8"/>
           <p:cNvSpPr txBox="1"/>
           <p:nvPr/>
         </p:nvSpPr>
         <p:spPr>
           <a:xfrm>
-            <a:off x="640080" y="6355080"/>
-            <a:ext cx="10881360" cy="274320"/>
+            <a:off x="640080" y="6382512"/>
+            <a:ext cx="10881360" cy="228600"/>
           </a:xfrm>
           <a:prstGeom prst="rect">
             <a:avLst/>
@@ -3707,10 +3801,11 @@
           <a:lstStyle/>
           <a:p>
             <a:pPr algn="ctr">
-              <a:defRPr sz="1000">
+              <a:defRPr sz="1000" b="0">
                 <a:solidFill>
                   <a:srgbClr val="B8C4B8"/>
                 </a:solidFill>
+                <a:latin typeface="Trebuchet MS"/>
               </a:defRPr>
             </a:pPr>
             <a:r>
@@ -3797,7 +3892,7 @@
         <p:spPr>
           <a:xfrm>
             <a:off x="640080" y="502920"/>
-            <a:ext cx="2011680" cy="320040"/>
+            <a:ext cx="2103120" cy="274320"/>
           </a:xfrm>
           <a:prstGeom prst="rect">
             <a:avLst/>
@@ -3815,6 +3910,7 @@
                 <a:solidFill>
                   <a:srgbClr val="D89B3D"/>
                 </a:solidFill>
+                <a:latin typeface="Trebuchet MS"/>
               </a:defRPr>
             </a:pPr>
             <a:r>
@@ -3831,8 +3927,8 @@
         </p:nvSpPr>
         <p:spPr>
           <a:xfrm>
-            <a:off x="640080" y="868680"/>
-            <a:ext cx="10881360" cy="1143000"/>
+            <a:off x="640080" y="841248"/>
+            <a:ext cx="10881360" cy="868680"/>
           </a:xfrm>
           <a:prstGeom prst="rect">
             <a:avLst/>
@@ -3846,7 +3942,7 @@
           <a:lstStyle/>
           <a:p>
             <a:pPr>
-              <a:defRPr sz="3800" b="1">
+              <a:defRPr sz="3400" b="1">
                 <a:solidFill>
                   <a:srgbClr val="F2F0E8"/>
                 </a:solidFill>
@@ -3854,7 +3950,7 @@
               </a:defRPr>
             </a:pPr>
             <a:r>
-              <a:t>Testing Plan</a:t>
+              <a:t>STEM Principles</a:t>
             </a:r>
           </a:p>
         </p:txBody>
@@ -3867,8 +3963,8 @@
         </p:nvSpPr>
         <p:spPr>
           <a:xfrm>
-            <a:off x="640080" y="2240280"/>
-            <a:ext cx="10881360" cy="3886200"/>
+            <a:off x="640080" y="2057400"/>
+            <a:ext cx="10881360" cy="4069080"/>
           </a:xfrm>
           <a:prstGeom prst="roundRect">
             <a:avLst/>
@@ -3912,8 +4008,8 @@
         </p:nvSpPr>
         <p:spPr>
           <a:xfrm>
-            <a:off x="960120" y="2487168"/>
-            <a:ext cx="10241280" cy="3429000"/>
+            <a:off x="960120" y="2331720"/>
+            <a:ext cx="10241280" cy="3611880"/>
           </a:xfrm>
           <a:prstGeom prst="rect">
             <a:avLst/>
@@ -3930,14 +4026,14 @@
               <a:spcAft>
                 <a:spcPts val="800"/>
               </a:spcAft>
-              <a:defRPr sz="1800">
+              <a:defRPr sz="2000">
                 <a:solidFill>
                   <a:srgbClr val="F2F0E8"/>
                 </a:solidFill>
               </a:defRPr>
             </a:pPr>
             <a:r>
-              <a:t>• Range test at multiple pressure levels.</a:t>
+              <a:t>• Pressure creates force: F = P x A.</a:t>
             </a:r>
           </a:p>
           <a:p>
@@ -3945,14 +4041,14 @@
               <a:spcAft>
                 <a:spcPts val="800"/>
               </a:spcAft>
-              <a:defRPr sz="1800">
+              <a:defRPr sz="2000">
                 <a:solidFill>
                   <a:srgbClr val="B8C4B8"/>
                 </a:solidFill>
               </a:defRPr>
             </a:pPr>
             <a:r>
-              <a:t>• Reload time test.</a:t>
+              <a:t>• Launch angle affects range.</a:t>
             </a:r>
           </a:p>
           <a:p>
@@ -3960,14 +4056,14 @@
               <a:spcAft>
                 <a:spcPts val="800"/>
               </a:spcAft>
-              <a:defRPr sz="1800">
+              <a:defRPr sz="2000">
                 <a:solidFill>
                   <a:srgbClr val="B8C4B8"/>
                 </a:solidFill>
               </a:defRPr>
             </a:pPr>
             <a:r>
-              <a:t>• Usability test with first-time user.</a:t>
+              <a:t>• Payload mass affects acceleration.</a:t>
             </a:r>
           </a:p>
           <a:p>
@@ -3975,14 +4071,14 @@
               <a:spcAft>
                 <a:spcPts val="800"/>
               </a:spcAft>
-              <a:defRPr sz="1800">
+              <a:defRPr sz="2000">
                 <a:solidFill>
                   <a:srgbClr val="B8C4B8"/>
                 </a:solidFill>
               </a:defRPr>
             </a:pPr>
             <a:r>
-              <a:t>• Leak check before launch.</a:t>
+              <a:t>• Air leakage reduces repeatability.</a:t>
             </a:r>
           </a:p>
           <a:p>
@@ -3990,14 +4086,14 @@
               <a:spcAft>
                 <a:spcPts val="800"/>
               </a:spcAft>
-              <a:defRPr sz="1800">
+              <a:defRPr sz="2000">
                 <a:solidFill>
                   <a:srgbClr val="B8C4B8"/>
                 </a:solidFill>
               </a:defRPr>
             </a:pPr>
             <a:r>
-              <a:t>• Safety checklist review.</a:t>
+              <a:t>• Safety factor limits operating pressure.</a:t>
             </a:r>
           </a:p>
         </p:txBody>
@@ -4010,8 +4106,8 @@
         </p:nvSpPr>
         <p:spPr>
           <a:xfrm>
-            <a:off x="640080" y="6355080"/>
-            <a:ext cx="10881360" cy="274320"/>
+            <a:off x="640080" y="6382512"/>
+            <a:ext cx="10881360" cy="228600"/>
           </a:xfrm>
           <a:prstGeom prst="rect">
             <a:avLst/>
@@ -4025,10 +4121,11 @@
           <a:lstStyle/>
           <a:p>
             <a:pPr algn="ctr">
-              <a:defRPr sz="1000">
+              <a:defRPr sz="1000" b="0">
                 <a:solidFill>
                   <a:srgbClr val="B8C4B8"/>
                 </a:solidFill>
+                <a:latin typeface="Trebuchet MS"/>
               </a:defRPr>
             </a:pPr>
             <a:r>
@@ -4115,7 +4212,7 @@
         <p:spPr>
           <a:xfrm>
             <a:off x="640080" y="502920"/>
-            <a:ext cx="2011680" cy="320040"/>
+            <a:ext cx="2103120" cy="274320"/>
           </a:xfrm>
           <a:prstGeom prst="rect">
             <a:avLst/>
@@ -4133,6 +4230,7 @@
                 <a:solidFill>
                   <a:srgbClr val="D89B3D"/>
                 </a:solidFill>
+                <a:latin typeface="Trebuchet MS"/>
               </a:defRPr>
             </a:pPr>
             <a:r>
@@ -4149,8 +4247,8 @@
         </p:nvSpPr>
         <p:spPr>
           <a:xfrm>
-            <a:off x="640080" y="868680"/>
-            <a:ext cx="10881360" cy="1143000"/>
+            <a:off x="640080" y="841248"/>
+            <a:ext cx="10881360" cy="868680"/>
           </a:xfrm>
           <a:prstGeom prst="rect">
             <a:avLst/>
@@ -4164,7 +4262,7 @@
           <a:lstStyle/>
           <a:p>
             <a:pPr>
-              <a:defRPr sz="3800" b="1">
+              <a:defRPr sz="3400" b="1">
                 <a:solidFill>
                   <a:srgbClr val="F2F0E8"/>
                 </a:solidFill>
@@ -4172,7 +4270,7 @@
               </a:defRPr>
             </a:pPr>
             <a:r>
-              <a:t>Placeholder Testing Results</a:t>
+              <a:t>User Manual Cycle</a:t>
             </a:r>
           </a:p>
         </p:txBody>
@@ -4185,8 +4283,8 @@
         </p:nvSpPr>
         <p:spPr>
           <a:xfrm>
-            <a:off x="640080" y="2240280"/>
-            <a:ext cx="10881360" cy="3886200"/>
+            <a:off x="640080" y="1965960"/>
+            <a:ext cx="5577840" cy="4297680"/>
           </a:xfrm>
           <a:prstGeom prst="roundRect">
             <a:avLst/>
@@ -4230,8 +4328,8 @@
         </p:nvSpPr>
         <p:spPr>
           <a:xfrm>
-            <a:off x="960120" y="2487168"/>
-            <a:ext cx="10241280" cy="3429000"/>
+            <a:off x="960120" y="2240280"/>
+            <a:ext cx="4983480" cy="3703320"/>
           </a:xfrm>
           <a:prstGeom prst="rect">
             <a:avLst/>
@@ -4246,105 +4344,157 @@
           <a:p>
             <a:pPr>
               <a:spcAft>
-                <a:spcPts val="800"/>
+                <a:spcPts val="600"/>
               </a:spcAft>
-              <a:defRPr sz="1800">
+              <a:defRPr sz="1700">
                 <a:solidFill>
                   <a:srgbClr val="F2F0E8"/>
                 </a:solidFill>
               </a:defRPr>
             </a:pPr>
             <a:r>
-              <a:t>• 30 psi: 35 ft average</a:t>
+              <a:t>• Fill: add air to selected safe pressure.</a:t>
             </a:r>
           </a:p>
           <a:p>
             <a:pPr>
               <a:spcAft>
-                <a:spcPts val="800"/>
+                <a:spcPts val="600"/>
               </a:spcAft>
-              <a:defRPr sz="1800">
+              <a:defRPr sz="1700">
                 <a:solidFill>
                   <a:srgbClr val="B8C4B8"/>
                 </a:solidFill>
               </a:defRPr>
             </a:pPr>
             <a:r>
-              <a:t>• 45 psi: 63 ft average</a:t>
+              <a:t>• Load: place the payload in the launch tube.</a:t>
             </a:r>
           </a:p>
           <a:p>
             <a:pPr>
               <a:spcAft>
-                <a:spcPts val="800"/>
+                <a:spcPts val="600"/>
               </a:spcAft>
-              <a:defRPr sz="1800">
+              <a:defRPr sz="1700">
                 <a:solidFill>
                   <a:srgbClr val="B8C4B8"/>
                 </a:solidFill>
               </a:defRPr>
             </a:pPr>
             <a:r>
-              <a:t>• 60 psi: 82 ft average</a:t>
+              <a:t>• Fire: aim into safe area and use release handle.</a:t>
             </a:r>
           </a:p>
           <a:p>
             <a:pPr>
               <a:spcAft>
-                <a:spcPts val="800"/>
+                <a:spcPts val="600"/>
               </a:spcAft>
-              <a:defRPr sz="1800">
+              <a:defRPr sz="1700">
                 <a:solidFill>
                   <a:srgbClr val="B8C4B8"/>
                 </a:solidFill>
               </a:defRPr>
             </a:pPr>
             <a:r>
-              <a:t>• Reload time: 35 seconds average</a:t>
+              <a:t>• Refill/Reload: reset valve path and prepare the next payload.</a:t>
             </a:r>
           </a:p>
           <a:p>
             <a:pPr>
               <a:spcAft>
-                <a:spcPts val="800"/>
+                <a:spcPts val="600"/>
               </a:spcAft>
-              <a:defRPr sz="1800">
+              <a:defRPr sz="1700">
                 <a:solidFill>
                   <a:srgbClr val="B8C4B8"/>
                 </a:solidFill>
               </a:defRPr>
             </a:pPr>
             <a:r>
-              <a:t>• User learning time: under 2 minutes</a:t>
-            </a:r>
-          </a:p>
-          <a:p>
-            <a:pPr>
-              <a:spcAft>
-                <a:spcPts val="800"/>
-              </a:spcAft>
-              <a:defRPr sz="1800">
-                <a:solidFill>
-                  <a:srgbClr val="B8C4B8"/>
-                </a:solidFill>
-              </a:defRPr>
-            </a:pPr>
-            <a:r>
-              <a:t>• Review: replace these with measured values.</a:t>
-            </a:r>
-          </a:p>
-        </p:txBody>
-      </p:sp>
-      <p:sp>
-        <p:nvSpPr>
-          <p:cNvPr id="7" name="TextBox 6"/>
+              <a:t>• Refire: repeat the same pressure and loading process.</a:t>
+            </a:r>
+          </a:p>
+        </p:txBody>
+      </p:sp>
+      <p:pic>
+        <p:nvPicPr>
+          <p:cNvPr id="7" name="Picture 6" descr="hardware-install.jpg"/>
+          <p:cNvPicPr>
+            <a:picLocks noChangeAspect="1"/>
+          </p:cNvPicPr>
+          <p:nvPr/>
+        </p:nvPicPr>
+        <p:blipFill>
+          <a:blip r:embed="rId2"/>
+          <a:stretch>
+            <a:fillRect/>
+          </a:stretch>
+        </p:blipFill>
+        <p:spPr>
+          <a:xfrm>
+            <a:off x="6446520" y="1965960"/>
+            <a:ext cx="5120640" cy="4297680"/>
+          </a:xfrm>
+          <a:prstGeom prst="rect">
+            <a:avLst/>
+          </a:prstGeom>
+        </p:spPr>
+      </p:pic>
+      <p:sp>
+        <p:nvSpPr>
+          <p:cNvPr id="8" name="Rectangle 7"/>
+          <p:cNvSpPr/>
+          <p:nvPr/>
+        </p:nvSpPr>
+        <p:spPr>
+          <a:xfrm>
+            <a:off x="6446520" y="1965960"/>
+            <a:ext cx="5120640" cy="4297680"/>
+          </a:xfrm>
+          <a:prstGeom prst="rect">
+            <a:avLst/>
+          </a:prstGeom>
+          <a:noFill/>
+          <a:ln w="12700">
+            <a:solidFill>
+              <a:srgbClr val="365144"/>
+            </a:solidFill>
+          </a:ln>
+        </p:spPr>
+        <p:style>
+          <a:lnRef idx="1">
+            <a:schemeClr val="accent1"/>
+          </a:lnRef>
+          <a:fillRef idx="3">
+            <a:schemeClr val="accent1"/>
+          </a:fillRef>
+          <a:effectRef idx="2">
+            <a:schemeClr val="accent1"/>
+          </a:effectRef>
+          <a:fontRef idx="minor">
+            <a:schemeClr val="lt1"/>
+          </a:fontRef>
+        </p:style>
+        <p:txBody>
+          <a:bodyPr rtlCol="0" anchor="ctr"/>
+          <a:lstStyle/>
+          <a:p>
+            <a:pPr algn="ctr"/>
+          </a:p>
+        </p:txBody>
+      </p:sp>
+      <p:sp>
+        <p:nvSpPr>
+          <p:cNvPr id="9" name="TextBox 8"/>
           <p:cNvSpPr txBox="1"/>
           <p:nvPr/>
         </p:nvSpPr>
         <p:spPr>
           <a:xfrm>
-            <a:off x="640080" y="6355080"/>
-            <a:ext cx="10881360" cy="274320"/>
+            <a:off x="640080" y="6382512"/>
+            <a:ext cx="10881360" cy="228600"/>
           </a:xfrm>
           <a:prstGeom prst="rect">
             <a:avLst/>
@@ -4358,10 +4508,11 @@
           <a:lstStyle/>
           <a:p>
             <a:pPr algn="ctr">
-              <a:defRPr sz="1000">
+              <a:defRPr sz="1000" b="0">
                 <a:solidFill>
                   <a:srgbClr val="B8C4B8"/>
                 </a:solidFill>
+                <a:latin typeface="Trebuchet MS"/>
               </a:defRPr>
             </a:pPr>
             <a:r>
@@ -4448,7 +4599,7 @@
         <p:spPr>
           <a:xfrm>
             <a:off x="640080" y="502920"/>
-            <a:ext cx="2011680" cy="320040"/>
+            <a:ext cx="2103120" cy="274320"/>
           </a:xfrm>
           <a:prstGeom prst="rect">
             <a:avLst/>
@@ -4466,6 +4617,7 @@
                 <a:solidFill>
                   <a:srgbClr val="D89B3D"/>
                 </a:solidFill>
+                <a:latin typeface="Trebuchet MS"/>
               </a:defRPr>
             </a:pPr>
             <a:r>
@@ -4482,8 +4634,8 @@
         </p:nvSpPr>
         <p:spPr>
           <a:xfrm>
-            <a:off x="640080" y="868680"/>
-            <a:ext cx="10881360" cy="1143000"/>
+            <a:off x="640080" y="841248"/>
+            <a:ext cx="10881360" cy="868680"/>
           </a:xfrm>
           <a:prstGeom prst="rect">
             <a:avLst/>
@@ -4497,7 +4649,7 @@
           <a:lstStyle/>
           <a:p>
             <a:pPr>
-              <a:defRPr sz="3800" b="1">
+              <a:defRPr sz="3400" b="1">
                 <a:solidFill>
                   <a:srgbClr val="F2F0E8"/>
                 </a:solidFill>
@@ -4505,7 +4657,7 @@
               </a:defRPr>
             </a:pPr>
             <a:r>
-              <a:t>Feedback and Modifications</a:t>
+              <a:t>Testing Plan</a:t>
             </a:r>
           </a:p>
         </p:txBody>
@@ -4518,8 +4670,8 @@
         </p:nvSpPr>
         <p:spPr>
           <a:xfrm>
-            <a:off x="640080" y="2240280"/>
-            <a:ext cx="10881360" cy="3886200"/>
+            <a:off x="640080" y="2057400"/>
+            <a:ext cx="10881360" cy="4069080"/>
           </a:xfrm>
           <a:prstGeom prst="roundRect">
             <a:avLst/>
@@ -4563,8 +4715,8 @@
         </p:nvSpPr>
         <p:spPr>
           <a:xfrm>
-            <a:off x="960120" y="2487168"/>
-            <a:ext cx="10241280" cy="3429000"/>
+            <a:off x="960120" y="2331720"/>
+            <a:ext cx="10241280" cy="3611880"/>
           </a:xfrm>
           <a:prstGeom prst="rect">
             <a:avLst/>
@@ -4581,14 +4733,14 @@
               <a:spcAft>
                 <a:spcPts val="800"/>
               </a:spcAft>
-              <a:defRPr sz="1800">
+              <a:defRPr sz="2000">
                 <a:solidFill>
                   <a:srgbClr val="F2F0E8"/>
                 </a:solidFill>
               </a:defRPr>
             </a:pPr>
             <a:r>
-              <a:t>• Setup was clearer than the old cannon.</a:t>
+              <a:t>• Range test at multiple pressure levels.</a:t>
             </a:r>
           </a:p>
           <a:p>
@@ -4596,14 +4748,14 @@
               <a:spcAft>
                 <a:spcPts val="800"/>
               </a:spcAft>
-              <a:defRPr sz="1800">
+              <a:defRPr sz="2000">
                 <a:solidFill>
                   <a:srgbClr val="B8C4B8"/>
                 </a:solidFill>
               </a:defRPr>
             </a:pPr>
             <a:r>
-              <a:t>• Gauge made operation easier to understand.</a:t>
+              <a:t>• Reload time test.</a:t>
             </a:r>
           </a:p>
           <a:p>
@@ -4611,14 +4763,14 @@
               <a:spcAft>
                 <a:spcPts val="800"/>
               </a:spcAft>
-              <a:defRPr sz="1800">
+              <a:defRPr sz="2000">
                 <a:solidFill>
                   <a:srgbClr val="B8C4B8"/>
                 </a:solidFill>
               </a:defRPr>
             </a:pPr>
             <a:r>
-              <a:t>• Range was useful for rallies and field events.</a:t>
+              <a:t>• Usability test with first-time user.</a:t>
             </a:r>
           </a:p>
           <a:p>
@@ -4626,14 +4778,14 @@
               <a:spcAft>
                 <a:spcPts val="800"/>
               </a:spcAft>
-              <a:defRPr sz="1800">
+              <a:defRPr sz="2000">
                 <a:solidFill>
                   <a:srgbClr val="B8C4B8"/>
                 </a:solidFill>
               </a:defRPr>
             </a:pPr>
             <a:r>
-              <a:t>• Permanent safety labeling is needed.</a:t>
+              <a:t>• Leak check before launch.</a:t>
             </a:r>
           </a:p>
           <a:p>
@@ -4641,14 +4793,14 @@
               <a:spcAft>
                 <a:spcPts val="800"/>
               </a:spcAft>
-              <a:defRPr sz="1800">
+              <a:defRPr sz="2000">
                 <a:solidFill>
                   <a:srgbClr val="B8C4B8"/>
                 </a:solidFill>
               </a:defRPr>
             </a:pPr>
             <a:r>
-              <a:t>• Next: brackets, checklist, payload testing, angle indicator, transport case.</a:t>
+              <a:t>• Safety checklist review.</a:t>
             </a:r>
           </a:p>
         </p:txBody>
@@ -4661,8 +4813,8 @@
         </p:nvSpPr>
         <p:spPr>
           <a:xfrm>
-            <a:off x="640080" y="6355080"/>
-            <a:ext cx="10881360" cy="274320"/>
+            <a:off x="640080" y="6382512"/>
+            <a:ext cx="10881360" cy="228600"/>
           </a:xfrm>
           <a:prstGeom prst="rect">
             <a:avLst/>
@@ -4676,10 +4828,11 @@
           <a:lstStyle/>
           <a:p>
             <a:pPr algn="ctr">
-              <a:defRPr sz="1000">
+              <a:defRPr sz="1000" b="0">
                 <a:solidFill>
                   <a:srgbClr val="B8C4B8"/>
                 </a:solidFill>
+                <a:latin typeface="Trebuchet MS"/>
               </a:defRPr>
             </a:pPr>
             <a:r>
@@ -4766,7 +4919,7 @@
         <p:spPr>
           <a:xfrm>
             <a:off x="640080" y="502920"/>
-            <a:ext cx="2011680" cy="320040"/>
+            <a:ext cx="2103120" cy="274320"/>
           </a:xfrm>
           <a:prstGeom prst="rect">
             <a:avLst/>
@@ -4784,6 +4937,7 @@
                 <a:solidFill>
                   <a:srgbClr val="D89B3D"/>
                 </a:solidFill>
+                <a:latin typeface="Trebuchet MS"/>
               </a:defRPr>
             </a:pPr>
             <a:r>
@@ -4800,8 +4954,8 @@
         </p:nvSpPr>
         <p:spPr>
           <a:xfrm>
-            <a:off x="640080" y="868680"/>
-            <a:ext cx="10881360" cy="1143000"/>
+            <a:off x="640080" y="841248"/>
+            <a:ext cx="10881360" cy="868680"/>
           </a:xfrm>
           <a:prstGeom prst="rect">
             <a:avLst/>
@@ -4815,7 +4969,7 @@
           <a:lstStyle/>
           <a:p>
             <a:pPr>
-              <a:defRPr sz="3800" b="1">
+              <a:defRPr sz="3400" b="1">
                 <a:solidFill>
                   <a:srgbClr val="F2F0E8"/>
                 </a:solidFill>
@@ -4823,7 +4977,7 @@
               </a:defRPr>
             </a:pPr>
             <a:r>
-              <a:t>Conclusion</a:t>
+              <a:t>Placeholder Testing Results</a:t>
             </a:r>
           </a:p>
         </p:txBody>
@@ -4836,8 +4990,8 @@
         </p:nvSpPr>
         <p:spPr>
           <a:xfrm>
-            <a:off x="640080" y="2240280"/>
-            <a:ext cx="10881360" cy="3886200"/>
+            <a:off x="640080" y="2057400"/>
+            <a:ext cx="10881360" cy="4069080"/>
           </a:xfrm>
           <a:prstGeom prst="roundRect">
             <a:avLst/>
@@ -4881,8 +5035,8 @@
         </p:nvSpPr>
         <p:spPr>
           <a:xfrm>
-            <a:off x="960120" y="2487168"/>
-            <a:ext cx="10241280" cy="3429000"/>
+            <a:off x="960120" y="2331720"/>
+            <a:ext cx="10241280" cy="3611880"/>
           </a:xfrm>
           <a:prstGeom prst="rect">
             <a:avLst/>
@@ -4899,14 +5053,14 @@
               <a:spcAft>
                 <a:spcPts val="800"/>
               </a:spcAft>
-              <a:defRPr sz="2200">
+              <a:defRPr sz="1700">
                 <a:solidFill>
                   <a:srgbClr val="F2F0E8"/>
                 </a:solidFill>
               </a:defRPr>
             </a:pPr>
             <a:r>
-              <a:t>• A school event launcher is successful when users can operate it safely and consistently.</a:t>
+              <a:t>• 30 psi: 35 ft average</a:t>
             </a:r>
           </a:p>
           <a:p>
@@ -4914,14 +5068,14 @@
               <a:spcAft>
                 <a:spcPts val="800"/>
               </a:spcAft>
-              <a:defRPr sz="2200">
+              <a:defRPr sz="1700">
                 <a:solidFill>
                   <a:srgbClr val="B8C4B8"/>
                 </a:solidFill>
               </a:defRPr>
             </a:pPr>
             <a:r>
-              <a:t>• The air pressure design better fits actual users than the original spring-loaded concept.</a:t>
+              <a:t>• 45 psi: 63 ft average</a:t>
             </a:r>
           </a:p>
           <a:p>
@@ -4929,14 +5083,59 @@
               <a:spcAft>
                 <a:spcPts val="800"/>
               </a:spcAft>
-              <a:defRPr sz="2200">
+              <a:defRPr sz="1700">
                 <a:solidFill>
                   <a:srgbClr val="B8C4B8"/>
                 </a:solidFill>
               </a:defRPr>
             </a:pPr>
             <a:r>
-              <a:t>• The pivot was an engineering decision based on evidence.</a:t>
+              <a:t>• 60 psi: 82 ft average</a:t>
+            </a:r>
+          </a:p>
+          <a:p>
+            <a:pPr>
+              <a:spcAft>
+                <a:spcPts val="800"/>
+              </a:spcAft>
+              <a:defRPr sz="1700">
+                <a:solidFill>
+                  <a:srgbClr val="B8C4B8"/>
+                </a:solidFill>
+              </a:defRPr>
+            </a:pPr>
+            <a:r>
+              <a:t>• Reload time: 35 seconds average</a:t>
+            </a:r>
+          </a:p>
+          <a:p>
+            <a:pPr>
+              <a:spcAft>
+                <a:spcPts val="800"/>
+              </a:spcAft>
+              <a:defRPr sz="1700">
+                <a:solidFill>
+                  <a:srgbClr val="B8C4B8"/>
+                </a:solidFill>
+              </a:defRPr>
+            </a:pPr>
+            <a:r>
+              <a:t>• User learning time: under 2 minutes</a:t>
+            </a:r>
+          </a:p>
+          <a:p>
+            <a:pPr>
+              <a:spcAft>
+                <a:spcPts val="800"/>
+              </a:spcAft>
+              <a:defRPr sz="1700">
+                <a:solidFill>
+                  <a:srgbClr val="B8C4B8"/>
+                </a:solidFill>
+              </a:defRPr>
+            </a:pPr>
+            <a:r>
+              <a:t>• Review: replace these with measured values.</a:t>
             </a:r>
           </a:p>
         </p:txBody>
@@ -4949,8 +5148,8 @@
         </p:nvSpPr>
         <p:spPr>
           <a:xfrm>
-            <a:off x="640080" y="6355080"/>
-            <a:ext cx="10881360" cy="274320"/>
+            <a:off x="640080" y="6382512"/>
+            <a:ext cx="10881360" cy="228600"/>
           </a:xfrm>
           <a:prstGeom prst="rect">
             <a:avLst/>
@@ -4964,10 +5163,688 @@
           <a:lstStyle/>
           <a:p>
             <a:pPr algn="ctr">
-              <a:defRPr sz="1000">
+              <a:defRPr sz="1000" b="0">
                 <a:solidFill>
                   <a:srgbClr val="B8C4B8"/>
                 </a:solidFill>
+                <a:latin typeface="Trebuchet MS"/>
+              </a:defRPr>
+            </a:pPr>
+            <a:r>
+              <a:t>Hudson Tien | PLTW Engineering Design and Development | Replace placeholder data before final submission</a:t>
+            </a:r>
+          </a:p>
+        </p:txBody>
+      </p:sp>
+    </p:spTree>
+  </p:cSld>
+  <p:clrMapOvr>
+    <a:masterClrMapping/>
+  </p:clrMapOvr>
+</p:sld>
+</file>
+
+<file path=ppt/slides/slide15.xml><?xml version="1.0" encoding="utf-8"?>
+<p:sld xmlns:a="http://schemas.openxmlformats.org/drawingml/2006/main" xmlns:p="http://schemas.openxmlformats.org/presentationml/2006/main" xmlns:r="http://schemas.openxmlformats.org/officeDocument/2006/relationships">
+  <p:cSld>
+    <p:bg>
+      <p:bgPr>
+        <a:solidFill>
+          <a:srgbClr val="101312"/>
+        </a:solidFill>
+        <a:effectLst/>
+      </p:bgPr>
+    </p:bg>
+    <p:spTree>
+      <p:nvGrpSpPr>
+        <p:cNvPr id="1" name=""/>
+        <p:cNvGrpSpPr/>
+        <p:nvPr/>
+      </p:nvGrpSpPr>
+      <p:grpSpPr/>
+      <p:sp>
+        <p:nvSpPr>
+          <p:cNvPr id="2" name="Rectangle 1"/>
+          <p:cNvSpPr/>
+          <p:nvPr/>
+        </p:nvSpPr>
+        <p:spPr>
+          <a:xfrm>
+            <a:off x="0" y="0"/>
+            <a:ext cx="12191695" cy="201168"/>
+          </a:xfrm>
+          <a:prstGeom prst="rect">
+            <a:avLst/>
+          </a:prstGeom>
+          <a:solidFill>
+            <a:srgbClr val="D89B3D"/>
+          </a:solidFill>
+          <a:ln>
+            <a:noFill/>
+          </a:ln>
+        </p:spPr>
+        <p:style>
+          <a:lnRef idx="1">
+            <a:schemeClr val="accent1"/>
+          </a:lnRef>
+          <a:fillRef idx="3">
+            <a:schemeClr val="accent1"/>
+          </a:fillRef>
+          <a:effectRef idx="2">
+            <a:schemeClr val="accent1"/>
+          </a:effectRef>
+          <a:fontRef idx="minor">
+            <a:schemeClr val="lt1"/>
+          </a:fontRef>
+        </p:style>
+        <p:txBody>
+          <a:bodyPr rtlCol="0" anchor="ctr"/>
+          <a:lstStyle/>
+          <a:p>
+            <a:pPr algn="ctr"/>
+          </a:p>
+        </p:txBody>
+      </p:sp>
+      <p:sp>
+        <p:nvSpPr>
+          <p:cNvPr id="3" name="TextBox 2"/>
+          <p:cNvSpPr txBox="1"/>
+          <p:nvPr/>
+        </p:nvSpPr>
+        <p:spPr>
+          <a:xfrm>
+            <a:off x="640080" y="502920"/>
+            <a:ext cx="2103120" cy="274320"/>
+          </a:xfrm>
+          <a:prstGeom prst="rect">
+            <a:avLst/>
+          </a:prstGeom>
+          <a:noFill/>
+        </p:spPr>
+        <p:txBody>
+          <a:bodyPr wrap="none">
+            <a:spAutoFit/>
+          </a:bodyPr>
+          <a:lstStyle/>
+          <a:p>
+            <a:pPr>
+              <a:defRPr sz="1200" b="1">
+                <a:solidFill>
+                  <a:srgbClr val="D89B3D"/>
+                </a:solidFill>
+                <a:latin typeface="Trebuchet MS"/>
+              </a:defRPr>
+            </a:pPr>
+            <a:r>
+              <a:t>Slide 15</a:t>
+            </a:r>
+          </a:p>
+        </p:txBody>
+      </p:sp>
+      <p:sp>
+        <p:nvSpPr>
+          <p:cNvPr id="4" name="TextBox 3"/>
+          <p:cNvSpPr txBox="1"/>
+          <p:nvPr/>
+        </p:nvSpPr>
+        <p:spPr>
+          <a:xfrm>
+            <a:off x="640080" y="841248"/>
+            <a:ext cx="10881360" cy="868680"/>
+          </a:xfrm>
+          <a:prstGeom prst="rect">
+            <a:avLst/>
+          </a:prstGeom>
+          <a:noFill/>
+        </p:spPr>
+        <p:txBody>
+          <a:bodyPr wrap="none">
+            <a:spAutoFit/>
+          </a:bodyPr>
+          <a:lstStyle/>
+          <a:p>
+            <a:pPr>
+              <a:defRPr sz="3400" b="1">
+                <a:solidFill>
+                  <a:srgbClr val="F2F0E8"/>
+                </a:solidFill>
+                <a:latin typeface="Georgia"/>
+              </a:defRPr>
+            </a:pPr>
+            <a:r>
+              <a:t>Feedback and Modifications</a:t>
+            </a:r>
+          </a:p>
+        </p:txBody>
+      </p:sp>
+      <p:sp>
+        <p:nvSpPr>
+          <p:cNvPr id="5" name="Rounded Rectangle 4"/>
+          <p:cNvSpPr/>
+          <p:nvPr/>
+        </p:nvSpPr>
+        <p:spPr>
+          <a:xfrm>
+            <a:off x="640080" y="1965960"/>
+            <a:ext cx="5577840" cy="4297680"/>
+          </a:xfrm>
+          <a:prstGeom prst="roundRect">
+            <a:avLst/>
+          </a:prstGeom>
+          <a:solidFill>
+            <a:srgbClr val="1E2D28"/>
+          </a:solidFill>
+          <a:ln>
+            <a:solidFill>
+              <a:srgbClr val="365144"/>
+            </a:solidFill>
+          </a:ln>
+        </p:spPr>
+        <p:style>
+          <a:lnRef idx="1">
+            <a:schemeClr val="accent1"/>
+          </a:lnRef>
+          <a:fillRef idx="3">
+            <a:schemeClr val="accent1"/>
+          </a:fillRef>
+          <a:effectRef idx="2">
+            <a:schemeClr val="accent1"/>
+          </a:effectRef>
+          <a:fontRef idx="minor">
+            <a:schemeClr val="lt1"/>
+          </a:fontRef>
+        </p:style>
+        <p:txBody>
+          <a:bodyPr rtlCol="0" anchor="ctr"/>
+          <a:lstStyle/>
+          <a:p>
+            <a:pPr algn="ctr"/>
+          </a:p>
+        </p:txBody>
+      </p:sp>
+      <p:sp>
+        <p:nvSpPr>
+          <p:cNvPr id="6" name="TextBox 5"/>
+          <p:cNvSpPr txBox="1"/>
+          <p:nvPr/>
+        </p:nvSpPr>
+        <p:spPr>
+          <a:xfrm>
+            <a:off x="960120" y="2240280"/>
+            <a:ext cx="4983480" cy="3703320"/>
+          </a:xfrm>
+          <a:prstGeom prst="rect">
+            <a:avLst/>
+          </a:prstGeom>
+          <a:noFill/>
+        </p:spPr>
+        <p:txBody>
+          <a:bodyPr wrap="none">
+            <a:spAutoFit/>
+          </a:bodyPr>
+          <a:lstStyle/>
+          <a:p>
+            <a:pPr>
+              <a:spcAft>
+                <a:spcPts val="600"/>
+              </a:spcAft>
+              <a:defRPr sz="1700">
+                <a:solidFill>
+                  <a:srgbClr val="F2F0E8"/>
+                </a:solidFill>
+              </a:defRPr>
+            </a:pPr>
+            <a:r>
+              <a:t>• Setup was clearer than the old cannon.</a:t>
+            </a:r>
+          </a:p>
+          <a:p>
+            <a:pPr>
+              <a:spcAft>
+                <a:spcPts val="600"/>
+              </a:spcAft>
+              <a:defRPr sz="1700">
+                <a:solidFill>
+                  <a:srgbClr val="B8C4B8"/>
+                </a:solidFill>
+              </a:defRPr>
+            </a:pPr>
+            <a:r>
+              <a:t>• Gauge made operation easier to understand.</a:t>
+            </a:r>
+          </a:p>
+          <a:p>
+            <a:pPr>
+              <a:spcAft>
+                <a:spcPts val="600"/>
+              </a:spcAft>
+              <a:defRPr sz="1700">
+                <a:solidFill>
+                  <a:srgbClr val="B8C4B8"/>
+                </a:solidFill>
+              </a:defRPr>
+            </a:pPr>
+            <a:r>
+              <a:t>• Range was useful for rallies and field events.</a:t>
+            </a:r>
+          </a:p>
+          <a:p>
+            <a:pPr>
+              <a:spcAft>
+                <a:spcPts val="600"/>
+              </a:spcAft>
+              <a:defRPr sz="1700">
+                <a:solidFill>
+                  <a:srgbClr val="B8C4B8"/>
+                </a:solidFill>
+              </a:defRPr>
+            </a:pPr>
+            <a:r>
+              <a:t>• Permanent safety labeling is needed.</a:t>
+            </a:r>
+          </a:p>
+          <a:p>
+            <a:pPr>
+              <a:spcAft>
+                <a:spcPts val="600"/>
+              </a:spcAft>
+              <a:defRPr sz="1700">
+                <a:solidFill>
+                  <a:srgbClr val="B8C4B8"/>
+                </a:solidFill>
+              </a:defRPr>
+            </a:pPr>
+            <a:r>
+              <a:t>• Next: brackets, checklist, payload testing, angle indicator, transport case.</a:t>
+            </a:r>
+          </a:p>
+        </p:txBody>
+      </p:sp>
+      <p:pic>
+        <p:nvPicPr>
+          <p:cNvPr id="7" name="Picture 6" descr="painted-assembly.jpg"/>
+          <p:cNvPicPr>
+            <a:picLocks noChangeAspect="1"/>
+          </p:cNvPicPr>
+          <p:nvPr/>
+        </p:nvPicPr>
+        <p:blipFill>
+          <a:blip r:embed="rId2"/>
+          <a:stretch>
+            <a:fillRect/>
+          </a:stretch>
+        </p:blipFill>
+        <p:spPr>
+          <a:xfrm>
+            <a:off x="6446520" y="1965960"/>
+            <a:ext cx="5120640" cy="4297680"/>
+          </a:xfrm>
+          <a:prstGeom prst="rect">
+            <a:avLst/>
+          </a:prstGeom>
+        </p:spPr>
+      </p:pic>
+      <p:sp>
+        <p:nvSpPr>
+          <p:cNvPr id="8" name="Rectangle 7"/>
+          <p:cNvSpPr/>
+          <p:nvPr/>
+        </p:nvSpPr>
+        <p:spPr>
+          <a:xfrm>
+            <a:off x="6446520" y="1965960"/>
+            <a:ext cx="5120640" cy="4297680"/>
+          </a:xfrm>
+          <a:prstGeom prst="rect">
+            <a:avLst/>
+          </a:prstGeom>
+          <a:noFill/>
+          <a:ln w="12700">
+            <a:solidFill>
+              <a:srgbClr val="365144"/>
+            </a:solidFill>
+          </a:ln>
+        </p:spPr>
+        <p:style>
+          <a:lnRef idx="1">
+            <a:schemeClr val="accent1"/>
+          </a:lnRef>
+          <a:fillRef idx="3">
+            <a:schemeClr val="accent1"/>
+          </a:fillRef>
+          <a:effectRef idx="2">
+            <a:schemeClr val="accent1"/>
+          </a:effectRef>
+          <a:fontRef idx="minor">
+            <a:schemeClr val="lt1"/>
+          </a:fontRef>
+        </p:style>
+        <p:txBody>
+          <a:bodyPr rtlCol="0" anchor="ctr"/>
+          <a:lstStyle/>
+          <a:p>
+            <a:pPr algn="ctr"/>
+          </a:p>
+        </p:txBody>
+      </p:sp>
+      <p:sp>
+        <p:nvSpPr>
+          <p:cNvPr id="9" name="TextBox 8"/>
+          <p:cNvSpPr txBox="1"/>
+          <p:nvPr/>
+        </p:nvSpPr>
+        <p:spPr>
+          <a:xfrm>
+            <a:off x="640080" y="6382512"/>
+            <a:ext cx="10881360" cy="228600"/>
+          </a:xfrm>
+          <a:prstGeom prst="rect">
+            <a:avLst/>
+          </a:prstGeom>
+          <a:noFill/>
+        </p:spPr>
+        <p:txBody>
+          <a:bodyPr wrap="none">
+            <a:spAutoFit/>
+          </a:bodyPr>
+          <a:lstStyle/>
+          <a:p>
+            <a:pPr algn="ctr">
+              <a:defRPr sz="1000" b="0">
+                <a:solidFill>
+                  <a:srgbClr val="B8C4B8"/>
+                </a:solidFill>
+                <a:latin typeface="Trebuchet MS"/>
+              </a:defRPr>
+            </a:pPr>
+            <a:r>
+              <a:t>Hudson Tien | PLTW Engineering Design and Development | Replace placeholder data before final submission</a:t>
+            </a:r>
+          </a:p>
+        </p:txBody>
+      </p:sp>
+    </p:spTree>
+  </p:cSld>
+  <p:clrMapOvr>
+    <a:masterClrMapping/>
+  </p:clrMapOvr>
+</p:sld>
+</file>
+
+<file path=ppt/slides/slide16.xml><?xml version="1.0" encoding="utf-8"?>
+<p:sld xmlns:a="http://schemas.openxmlformats.org/drawingml/2006/main" xmlns:p="http://schemas.openxmlformats.org/presentationml/2006/main" xmlns:r="http://schemas.openxmlformats.org/officeDocument/2006/relationships">
+  <p:cSld>
+    <p:bg>
+      <p:bgPr>
+        <a:solidFill>
+          <a:srgbClr val="101312"/>
+        </a:solidFill>
+        <a:effectLst/>
+      </p:bgPr>
+    </p:bg>
+    <p:spTree>
+      <p:nvGrpSpPr>
+        <p:cNvPr id="1" name=""/>
+        <p:cNvGrpSpPr/>
+        <p:nvPr/>
+      </p:nvGrpSpPr>
+      <p:grpSpPr/>
+      <p:sp>
+        <p:nvSpPr>
+          <p:cNvPr id="2" name="Rectangle 1"/>
+          <p:cNvSpPr/>
+          <p:nvPr/>
+        </p:nvSpPr>
+        <p:spPr>
+          <a:xfrm>
+            <a:off x="0" y="0"/>
+            <a:ext cx="12191695" cy="201168"/>
+          </a:xfrm>
+          <a:prstGeom prst="rect">
+            <a:avLst/>
+          </a:prstGeom>
+          <a:solidFill>
+            <a:srgbClr val="D89B3D"/>
+          </a:solidFill>
+          <a:ln>
+            <a:noFill/>
+          </a:ln>
+        </p:spPr>
+        <p:style>
+          <a:lnRef idx="1">
+            <a:schemeClr val="accent1"/>
+          </a:lnRef>
+          <a:fillRef idx="3">
+            <a:schemeClr val="accent1"/>
+          </a:fillRef>
+          <a:effectRef idx="2">
+            <a:schemeClr val="accent1"/>
+          </a:effectRef>
+          <a:fontRef idx="minor">
+            <a:schemeClr val="lt1"/>
+          </a:fontRef>
+        </p:style>
+        <p:txBody>
+          <a:bodyPr rtlCol="0" anchor="ctr"/>
+          <a:lstStyle/>
+          <a:p>
+            <a:pPr algn="ctr"/>
+          </a:p>
+        </p:txBody>
+      </p:sp>
+      <p:sp>
+        <p:nvSpPr>
+          <p:cNvPr id="3" name="TextBox 2"/>
+          <p:cNvSpPr txBox="1"/>
+          <p:nvPr/>
+        </p:nvSpPr>
+        <p:spPr>
+          <a:xfrm>
+            <a:off x="640080" y="502920"/>
+            <a:ext cx="2103120" cy="274320"/>
+          </a:xfrm>
+          <a:prstGeom prst="rect">
+            <a:avLst/>
+          </a:prstGeom>
+          <a:noFill/>
+        </p:spPr>
+        <p:txBody>
+          <a:bodyPr wrap="none">
+            <a:spAutoFit/>
+          </a:bodyPr>
+          <a:lstStyle/>
+          <a:p>
+            <a:pPr>
+              <a:defRPr sz="1200" b="1">
+                <a:solidFill>
+                  <a:srgbClr val="D89B3D"/>
+                </a:solidFill>
+                <a:latin typeface="Trebuchet MS"/>
+              </a:defRPr>
+            </a:pPr>
+            <a:r>
+              <a:t>Slide 16</a:t>
+            </a:r>
+          </a:p>
+        </p:txBody>
+      </p:sp>
+      <p:sp>
+        <p:nvSpPr>
+          <p:cNvPr id="4" name="TextBox 3"/>
+          <p:cNvSpPr txBox="1"/>
+          <p:nvPr/>
+        </p:nvSpPr>
+        <p:spPr>
+          <a:xfrm>
+            <a:off x="640080" y="841248"/>
+            <a:ext cx="10881360" cy="868680"/>
+          </a:xfrm>
+          <a:prstGeom prst="rect">
+            <a:avLst/>
+          </a:prstGeom>
+          <a:noFill/>
+        </p:spPr>
+        <p:txBody>
+          <a:bodyPr wrap="none">
+            <a:spAutoFit/>
+          </a:bodyPr>
+          <a:lstStyle/>
+          <a:p>
+            <a:pPr>
+              <a:defRPr sz="3400" b="1">
+                <a:solidFill>
+                  <a:srgbClr val="F2F0E8"/>
+                </a:solidFill>
+                <a:latin typeface="Georgia"/>
+              </a:defRPr>
+            </a:pPr>
+            <a:r>
+              <a:t>Conclusion</a:t>
+            </a:r>
+          </a:p>
+        </p:txBody>
+      </p:sp>
+      <p:sp>
+        <p:nvSpPr>
+          <p:cNvPr id="5" name="Rounded Rectangle 4"/>
+          <p:cNvSpPr/>
+          <p:nvPr/>
+        </p:nvSpPr>
+        <p:spPr>
+          <a:xfrm>
+            <a:off x="640080" y="2057400"/>
+            <a:ext cx="10881360" cy="4069080"/>
+          </a:xfrm>
+          <a:prstGeom prst="roundRect">
+            <a:avLst/>
+          </a:prstGeom>
+          <a:solidFill>
+            <a:srgbClr val="1E2D28"/>
+          </a:solidFill>
+          <a:ln>
+            <a:solidFill>
+              <a:srgbClr val="365144"/>
+            </a:solidFill>
+          </a:ln>
+        </p:spPr>
+        <p:style>
+          <a:lnRef idx="1">
+            <a:schemeClr val="accent1"/>
+          </a:lnRef>
+          <a:fillRef idx="3">
+            <a:schemeClr val="accent1"/>
+          </a:fillRef>
+          <a:effectRef idx="2">
+            <a:schemeClr val="accent1"/>
+          </a:effectRef>
+          <a:fontRef idx="minor">
+            <a:schemeClr val="lt1"/>
+          </a:fontRef>
+        </p:style>
+        <p:txBody>
+          <a:bodyPr rtlCol="0" anchor="ctr"/>
+          <a:lstStyle/>
+          <a:p>
+            <a:pPr algn="ctr"/>
+          </a:p>
+        </p:txBody>
+      </p:sp>
+      <p:sp>
+        <p:nvSpPr>
+          <p:cNvPr id="6" name="TextBox 5"/>
+          <p:cNvSpPr txBox="1"/>
+          <p:nvPr/>
+        </p:nvSpPr>
+        <p:spPr>
+          <a:xfrm>
+            <a:off x="960120" y="2331720"/>
+            <a:ext cx="10241280" cy="3611880"/>
+          </a:xfrm>
+          <a:prstGeom prst="rect">
+            <a:avLst/>
+          </a:prstGeom>
+          <a:noFill/>
+        </p:spPr>
+        <p:txBody>
+          <a:bodyPr wrap="none">
+            <a:spAutoFit/>
+          </a:bodyPr>
+          <a:lstStyle/>
+          <a:p>
+            <a:pPr>
+              <a:spcAft>
+                <a:spcPts val="800"/>
+              </a:spcAft>
+              <a:defRPr sz="2000">
+                <a:solidFill>
+                  <a:srgbClr val="F2F0E8"/>
+                </a:solidFill>
+              </a:defRPr>
+            </a:pPr>
+            <a:r>
+              <a:t>• A school event launcher is successful when users can operate it safely and consistently.</a:t>
+            </a:r>
+          </a:p>
+          <a:p>
+            <a:pPr>
+              <a:spcAft>
+                <a:spcPts val="800"/>
+              </a:spcAft>
+              <a:defRPr sz="2000">
+                <a:solidFill>
+                  <a:srgbClr val="B8C4B8"/>
+                </a:solidFill>
+              </a:defRPr>
+            </a:pPr>
+            <a:r>
+              <a:t>• The air pressure design better fits actual users than the original spring-loaded concept.</a:t>
+            </a:r>
+          </a:p>
+          <a:p>
+            <a:pPr>
+              <a:spcAft>
+                <a:spcPts val="800"/>
+              </a:spcAft>
+              <a:defRPr sz="2000">
+                <a:solidFill>
+                  <a:srgbClr val="B8C4B8"/>
+                </a:solidFill>
+              </a:defRPr>
+            </a:pPr>
+            <a:r>
+              <a:t>• The pivot was an engineering decision based on evidence.</a:t>
+            </a:r>
+          </a:p>
+        </p:txBody>
+      </p:sp>
+      <p:sp>
+        <p:nvSpPr>
+          <p:cNvPr id="7" name="TextBox 6"/>
+          <p:cNvSpPr txBox="1"/>
+          <p:nvPr/>
+        </p:nvSpPr>
+        <p:spPr>
+          <a:xfrm>
+            <a:off x="640080" y="6382512"/>
+            <a:ext cx="10881360" cy="228600"/>
+          </a:xfrm>
+          <a:prstGeom prst="rect">
+            <a:avLst/>
+          </a:prstGeom>
+          <a:noFill/>
+        </p:spPr>
+        <p:txBody>
+          <a:bodyPr wrap="none">
+            <a:spAutoFit/>
+          </a:bodyPr>
+          <a:lstStyle/>
+          <a:p>
+            <a:pPr algn="ctr">
+              <a:defRPr sz="1000" b="0">
+                <a:solidFill>
+                  <a:srgbClr val="B8C4B8"/>
+                </a:solidFill>
+                <a:latin typeface="Trebuchet MS"/>
               </a:defRPr>
             </a:pPr>
             <a:r>
@@ -5054,7 +5931,7 @@
         <p:spPr>
           <a:xfrm>
             <a:off x="640080" y="502920"/>
-            <a:ext cx="2011680" cy="320040"/>
+            <a:ext cx="2103120" cy="274320"/>
           </a:xfrm>
           <a:prstGeom prst="rect">
             <a:avLst/>
@@ -5072,6 +5949,7 @@
                 <a:solidFill>
                   <a:srgbClr val="D89B3D"/>
                 </a:solidFill>
+                <a:latin typeface="Trebuchet MS"/>
               </a:defRPr>
             </a:pPr>
             <a:r>
@@ -5088,8 +5966,8 @@
         </p:nvSpPr>
         <p:spPr>
           <a:xfrm>
-            <a:off x="640080" y="868680"/>
-            <a:ext cx="10881360" cy="1143000"/>
+            <a:off x="640080" y="841248"/>
+            <a:ext cx="10881360" cy="868680"/>
           </a:xfrm>
           <a:prstGeom prst="rect">
             <a:avLst/>
@@ -5103,7 +5981,7 @@
           <a:lstStyle/>
           <a:p>
             <a:pPr>
-              <a:defRPr sz="3800" b="1">
+              <a:defRPr sz="3400" b="1">
                 <a:solidFill>
                   <a:srgbClr val="F2F0E8"/>
                 </a:solidFill>
@@ -5124,8 +6002,8 @@
         </p:nvSpPr>
         <p:spPr>
           <a:xfrm>
-            <a:off x="640080" y="2240280"/>
-            <a:ext cx="10881360" cy="3886200"/>
+            <a:off x="640080" y="2057400"/>
+            <a:ext cx="10881360" cy="4069080"/>
           </a:xfrm>
           <a:prstGeom prst="roundRect">
             <a:avLst/>
@@ -5169,8 +6047,8 @@
         </p:nvSpPr>
         <p:spPr>
           <a:xfrm>
-            <a:off x="960120" y="2487168"/>
-            <a:ext cx="10241280" cy="3429000"/>
+            <a:off x="960120" y="2331720"/>
+            <a:ext cx="10241280" cy="3611880"/>
           </a:xfrm>
           <a:prstGeom prst="rect">
             <a:avLst/>
@@ -5187,7 +6065,7 @@
               <a:spcAft>
                 <a:spcPts val="800"/>
               </a:spcAft>
-              <a:defRPr sz="1800">
+              <a:defRPr sz="2000">
                 <a:solidFill>
                   <a:srgbClr val="F2F0E8"/>
                 </a:solidFill>
@@ -5202,7 +6080,7 @@
               <a:spcAft>
                 <a:spcPts val="800"/>
               </a:spcAft>
-              <a:defRPr sz="1800">
+              <a:defRPr sz="2000">
                 <a:solidFill>
                   <a:srgbClr val="B8C4B8"/>
                 </a:solidFill>
@@ -5217,7 +6095,7 @@
               <a:spcAft>
                 <a:spcPts val="800"/>
               </a:spcAft>
-              <a:defRPr sz="1800">
+              <a:defRPr sz="2000">
                 <a:solidFill>
                   <a:srgbClr val="B8C4B8"/>
                 </a:solidFill>
@@ -5232,7 +6110,7 @@
               <a:spcAft>
                 <a:spcPts val="800"/>
               </a:spcAft>
-              <a:defRPr sz="1800">
+              <a:defRPr sz="2000">
                 <a:solidFill>
                   <a:srgbClr val="B8C4B8"/>
                 </a:solidFill>
@@ -5247,7 +6125,7 @@
               <a:spcAft>
                 <a:spcPts val="800"/>
               </a:spcAft>
-              <a:defRPr sz="1800">
+              <a:defRPr sz="2000">
                 <a:solidFill>
                   <a:srgbClr val="B8C4B8"/>
                 </a:solidFill>
@@ -5267,8 +6145,8 @@
         </p:nvSpPr>
         <p:spPr>
           <a:xfrm>
-            <a:off x="640080" y="6355080"/>
-            <a:ext cx="10881360" cy="274320"/>
+            <a:off x="640080" y="6382512"/>
+            <a:ext cx="10881360" cy="228600"/>
           </a:xfrm>
           <a:prstGeom prst="rect">
             <a:avLst/>
@@ -5282,10 +6160,11 @@
           <a:lstStyle/>
           <a:p>
             <a:pPr algn="ctr">
-              <a:defRPr sz="1000">
+              <a:defRPr sz="1000" b="0">
                 <a:solidFill>
                   <a:srgbClr val="B8C4B8"/>
                 </a:solidFill>
+                <a:latin typeface="Trebuchet MS"/>
               </a:defRPr>
             </a:pPr>
             <a:r>
@@ -5372,7 +6251,7 @@
         <p:spPr>
           <a:xfrm>
             <a:off x="640080" y="502920"/>
-            <a:ext cx="2011680" cy="320040"/>
+            <a:ext cx="2103120" cy="274320"/>
           </a:xfrm>
           <a:prstGeom prst="rect">
             <a:avLst/>
@@ -5390,6 +6269,7 @@
                 <a:solidFill>
                   <a:srgbClr val="D89B3D"/>
                 </a:solidFill>
+                <a:latin typeface="Trebuchet MS"/>
               </a:defRPr>
             </a:pPr>
             <a:r>
@@ -5406,8 +6286,8 @@
         </p:nvSpPr>
         <p:spPr>
           <a:xfrm>
-            <a:off x="640080" y="868680"/>
-            <a:ext cx="10881360" cy="1143000"/>
+            <a:off x="640080" y="841248"/>
+            <a:ext cx="10881360" cy="868680"/>
           </a:xfrm>
           <a:prstGeom prst="rect">
             <a:avLst/>
@@ -5421,7 +6301,7 @@
           <a:lstStyle/>
           <a:p>
             <a:pPr>
-              <a:defRPr sz="3800" b="1">
+              <a:defRPr sz="3400" b="1">
                 <a:solidFill>
                   <a:srgbClr val="F2F0E8"/>
                 </a:solidFill>
@@ -5442,8 +6322,8 @@
         </p:nvSpPr>
         <p:spPr>
           <a:xfrm>
-            <a:off x="640080" y="2240280"/>
-            <a:ext cx="10881360" cy="3886200"/>
+            <a:off x="640080" y="2057400"/>
+            <a:ext cx="10881360" cy="4069080"/>
           </a:xfrm>
           <a:prstGeom prst="roundRect">
             <a:avLst/>
@@ -5487,8 +6367,8 @@
         </p:nvSpPr>
         <p:spPr>
           <a:xfrm>
-            <a:off x="960120" y="2487168"/>
-            <a:ext cx="10241280" cy="3429000"/>
+            <a:off x="960120" y="2331720"/>
+            <a:ext cx="10241280" cy="3611880"/>
           </a:xfrm>
           <a:prstGeom prst="rect">
             <a:avLst/>
@@ -5505,7 +6385,7 @@
               <a:spcAft>
                 <a:spcPts val="800"/>
               </a:spcAft>
-              <a:defRPr sz="2200">
+              <a:defRPr sz="2000">
                 <a:solidFill>
                   <a:srgbClr val="F2F0E8"/>
                 </a:solidFill>
@@ -5520,7 +6400,7 @@
               <a:spcAft>
                 <a:spcPts val="800"/>
               </a:spcAft>
-              <a:defRPr sz="2200">
+              <a:defRPr sz="2000">
                 <a:solidFill>
                   <a:srgbClr val="B8C4B8"/>
                 </a:solidFill>
@@ -5535,7 +6415,7 @@
               <a:spcAft>
                 <a:spcPts val="800"/>
               </a:spcAft>
-              <a:defRPr sz="2200">
+              <a:defRPr sz="2000">
                 <a:solidFill>
                   <a:srgbClr val="B8C4B8"/>
                 </a:solidFill>
@@ -5555,8 +6435,8 @@
         </p:nvSpPr>
         <p:spPr>
           <a:xfrm>
-            <a:off x="640080" y="6355080"/>
-            <a:ext cx="10881360" cy="274320"/>
+            <a:off x="640080" y="6382512"/>
+            <a:ext cx="10881360" cy="228600"/>
           </a:xfrm>
           <a:prstGeom prst="rect">
             <a:avLst/>
@@ -5570,10 +6450,11 @@
           <a:lstStyle/>
           <a:p>
             <a:pPr algn="ctr">
-              <a:defRPr sz="1000">
+              <a:defRPr sz="1000" b="0">
                 <a:solidFill>
                   <a:srgbClr val="B8C4B8"/>
                 </a:solidFill>
+                <a:latin typeface="Trebuchet MS"/>
               </a:defRPr>
             </a:pPr>
             <a:r>
@@ -5660,7 +6541,7 @@
         <p:spPr>
           <a:xfrm>
             <a:off x="640080" y="502920"/>
-            <a:ext cx="2011680" cy="320040"/>
+            <a:ext cx="2103120" cy="274320"/>
           </a:xfrm>
           <a:prstGeom prst="rect">
             <a:avLst/>
@@ -5678,6 +6559,7 @@
                 <a:solidFill>
                   <a:srgbClr val="D89B3D"/>
                 </a:solidFill>
+                <a:latin typeface="Trebuchet MS"/>
               </a:defRPr>
             </a:pPr>
             <a:r>
@@ -5694,8 +6576,8 @@
         </p:nvSpPr>
         <p:spPr>
           <a:xfrm>
-            <a:off x="640080" y="868680"/>
-            <a:ext cx="10881360" cy="1143000"/>
+            <a:off x="640080" y="841248"/>
+            <a:ext cx="10881360" cy="868680"/>
           </a:xfrm>
           <a:prstGeom prst="rect">
             <a:avLst/>
@@ -5709,7 +6591,7 @@
           <a:lstStyle/>
           <a:p>
             <a:pPr>
-              <a:defRPr sz="3800" b="1">
+              <a:defRPr sz="3400" b="1">
                 <a:solidFill>
                   <a:srgbClr val="F2F0E8"/>
                 </a:solidFill>
@@ -5730,8 +6612,8 @@
         </p:nvSpPr>
         <p:spPr>
           <a:xfrm>
-            <a:off x="640080" y="2240280"/>
-            <a:ext cx="10881360" cy="3886200"/>
+            <a:off x="640080" y="2057400"/>
+            <a:ext cx="10881360" cy="4069080"/>
           </a:xfrm>
           <a:prstGeom prst="roundRect">
             <a:avLst/>
@@ -5775,8 +6657,8 @@
         </p:nvSpPr>
         <p:spPr>
           <a:xfrm>
-            <a:off x="960120" y="2487168"/>
-            <a:ext cx="10241280" cy="3429000"/>
+            <a:off x="960120" y="2331720"/>
+            <a:ext cx="10241280" cy="3611880"/>
           </a:xfrm>
           <a:prstGeom prst="rect">
             <a:avLst/>
@@ -5793,7 +6675,7 @@
               <a:spcAft>
                 <a:spcPts val="800"/>
               </a:spcAft>
-              <a:defRPr sz="2200">
+              <a:defRPr sz="2000">
                 <a:solidFill>
                   <a:srgbClr val="F2F0E8"/>
                 </a:solidFill>
@@ -5808,7 +6690,7 @@
               <a:spcAft>
                 <a:spcPts val="800"/>
               </a:spcAft>
-              <a:defRPr sz="2200">
+              <a:defRPr sz="2000">
                 <a:solidFill>
                   <a:srgbClr val="B8C4B8"/>
                 </a:solidFill>
@@ -5823,7 +6705,7 @@
               <a:spcAft>
                 <a:spcPts val="800"/>
               </a:spcAft>
-              <a:defRPr sz="2200">
+              <a:defRPr sz="2000">
                 <a:solidFill>
                   <a:srgbClr val="B8C4B8"/>
                 </a:solidFill>
@@ -5838,7 +6720,7 @@
               <a:spcAft>
                 <a:spcPts val="800"/>
               </a:spcAft>
-              <a:defRPr sz="2200">
+              <a:defRPr sz="2000">
                 <a:solidFill>
                   <a:srgbClr val="B8C4B8"/>
                 </a:solidFill>
@@ -5858,8 +6740,8 @@
         </p:nvSpPr>
         <p:spPr>
           <a:xfrm>
-            <a:off x="640080" y="6355080"/>
-            <a:ext cx="10881360" cy="274320"/>
+            <a:off x="640080" y="6382512"/>
+            <a:ext cx="10881360" cy="228600"/>
           </a:xfrm>
           <a:prstGeom prst="rect">
             <a:avLst/>
@@ -5873,10 +6755,11 @@
           <a:lstStyle/>
           <a:p>
             <a:pPr algn="ctr">
-              <a:defRPr sz="1000">
+              <a:defRPr sz="1000" b="0">
                 <a:solidFill>
                   <a:srgbClr val="B8C4B8"/>
                 </a:solidFill>
+                <a:latin typeface="Trebuchet MS"/>
               </a:defRPr>
             </a:pPr>
             <a:r>
@@ -5963,7 +6846,7 @@
         <p:spPr>
           <a:xfrm>
             <a:off x="640080" y="502920"/>
-            <a:ext cx="2011680" cy="320040"/>
+            <a:ext cx="2103120" cy="274320"/>
           </a:xfrm>
           <a:prstGeom prst="rect">
             <a:avLst/>
@@ -5981,6 +6864,7 @@
                 <a:solidFill>
                   <a:srgbClr val="D89B3D"/>
                 </a:solidFill>
+                <a:latin typeface="Trebuchet MS"/>
               </a:defRPr>
             </a:pPr>
             <a:r>
@@ -5997,8 +6881,8 @@
         </p:nvSpPr>
         <p:spPr>
           <a:xfrm>
-            <a:off x="640080" y="868680"/>
-            <a:ext cx="10881360" cy="1143000"/>
+            <a:off x="640080" y="841248"/>
+            <a:ext cx="10881360" cy="868680"/>
           </a:xfrm>
           <a:prstGeom prst="rect">
             <a:avLst/>
@@ -6012,7 +6896,7 @@
           <a:lstStyle/>
           <a:p>
             <a:pPr>
-              <a:defRPr sz="3800" b="1">
+              <a:defRPr sz="3400" b="1">
                 <a:solidFill>
                   <a:srgbClr val="F2F0E8"/>
                 </a:solidFill>
@@ -6033,8 +6917,8 @@
         </p:nvSpPr>
         <p:spPr>
           <a:xfrm>
-            <a:off x="640080" y="2240280"/>
-            <a:ext cx="10881360" cy="3886200"/>
+            <a:off x="640080" y="2057400"/>
+            <a:ext cx="10881360" cy="4069080"/>
           </a:xfrm>
           <a:prstGeom prst="roundRect">
             <a:avLst/>
@@ -6078,8 +6962,8 @@
         </p:nvSpPr>
         <p:spPr>
           <a:xfrm>
-            <a:off x="960120" y="2487168"/>
-            <a:ext cx="10241280" cy="3429000"/>
+            <a:off x="960120" y="2331720"/>
+            <a:ext cx="10241280" cy="3611880"/>
           </a:xfrm>
           <a:prstGeom prst="rect">
             <a:avLst/>
@@ -6096,7 +6980,7 @@
               <a:spcAft>
                 <a:spcPts val="800"/>
               </a:spcAft>
-              <a:defRPr sz="2200">
+              <a:defRPr sz="2000">
                 <a:solidFill>
                   <a:srgbClr val="F2F0E8"/>
                 </a:solidFill>
@@ -6111,7 +6995,7 @@
               <a:spcAft>
                 <a:spcPts val="800"/>
               </a:spcAft>
-              <a:defRPr sz="2200">
+              <a:defRPr sz="2000">
                 <a:solidFill>
                   <a:srgbClr val="B8C4B8"/>
                 </a:solidFill>
@@ -6126,7 +7010,7 @@
               <a:spcAft>
                 <a:spcPts val="800"/>
               </a:spcAft>
-              <a:defRPr sz="2200">
+              <a:defRPr sz="2000">
                 <a:solidFill>
                   <a:srgbClr val="B8C4B8"/>
                 </a:solidFill>
@@ -6141,7 +7025,7 @@
               <a:spcAft>
                 <a:spcPts val="800"/>
               </a:spcAft>
-              <a:defRPr sz="2200">
+              <a:defRPr sz="2000">
                 <a:solidFill>
                   <a:srgbClr val="B8C4B8"/>
                 </a:solidFill>
@@ -6161,8 +7045,8 @@
         </p:nvSpPr>
         <p:spPr>
           <a:xfrm>
-            <a:off x="640080" y="6355080"/>
-            <a:ext cx="10881360" cy="274320"/>
+            <a:off x="640080" y="6382512"/>
+            <a:ext cx="10881360" cy="228600"/>
           </a:xfrm>
           <a:prstGeom prst="rect">
             <a:avLst/>
@@ -6176,10 +7060,11 @@
           <a:lstStyle/>
           <a:p>
             <a:pPr algn="ctr">
-              <a:defRPr sz="1000">
+              <a:defRPr sz="1000" b="0">
                 <a:solidFill>
                   <a:srgbClr val="B8C4B8"/>
                 </a:solidFill>
+                <a:latin typeface="Trebuchet MS"/>
               </a:defRPr>
             </a:pPr>
             <a:r>
@@ -6266,7 +7151,7 @@
         <p:spPr>
           <a:xfrm>
             <a:off x="640080" y="502920"/>
-            <a:ext cx="2011680" cy="320040"/>
+            <a:ext cx="2103120" cy="274320"/>
           </a:xfrm>
           <a:prstGeom prst="rect">
             <a:avLst/>
@@ -6284,6 +7169,7 @@
                 <a:solidFill>
                   <a:srgbClr val="D89B3D"/>
                 </a:solidFill>
+                <a:latin typeface="Trebuchet MS"/>
               </a:defRPr>
             </a:pPr>
             <a:r>
@@ -6300,8 +7186,8 @@
         </p:nvSpPr>
         <p:spPr>
           <a:xfrm>
-            <a:off x="640080" y="868680"/>
-            <a:ext cx="10881360" cy="1143000"/>
+            <a:off x="640080" y="841248"/>
+            <a:ext cx="10881360" cy="868680"/>
           </a:xfrm>
           <a:prstGeom prst="rect">
             <a:avLst/>
@@ -6315,7 +7201,7 @@
           <a:lstStyle/>
           <a:p>
             <a:pPr>
-              <a:defRPr sz="3800" b="1">
+              <a:defRPr sz="3400" b="1">
                 <a:solidFill>
                   <a:srgbClr val="F2F0E8"/>
                 </a:solidFill>
@@ -6336,8 +7222,8 @@
         </p:nvSpPr>
         <p:spPr>
           <a:xfrm>
-            <a:off x="640080" y="2240280"/>
-            <a:ext cx="10881360" cy="3886200"/>
+            <a:off x="640080" y="1965960"/>
+            <a:ext cx="5577840" cy="4297680"/>
           </a:xfrm>
           <a:prstGeom prst="roundRect">
             <a:avLst/>
@@ -6381,8 +7267,8 @@
         </p:nvSpPr>
         <p:spPr>
           <a:xfrm>
-            <a:off x="960120" y="2487168"/>
-            <a:ext cx="10241280" cy="3429000"/>
+            <a:off x="960120" y="2240280"/>
+            <a:ext cx="4983480" cy="3703320"/>
           </a:xfrm>
           <a:prstGeom prst="rect">
             <a:avLst/>
@@ -6397,9 +7283,9 @@
           <a:p>
             <a:pPr>
               <a:spcAft>
-                <a:spcPts val="800"/>
+                <a:spcPts val="600"/>
               </a:spcAft>
-              <a:defRPr sz="2200">
+              <a:defRPr sz="2000">
                 <a:solidFill>
                   <a:srgbClr val="F2F0E8"/>
                 </a:solidFill>
@@ -6412,9 +7298,9 @@
           <a:p>
             <a:pPr>
               <a:spcAft>
-                <a:spcPts val="800"/>
+                <a:spcPts val="600"/>
               </a:spcAft>
-              <a:defRPr sz="2200">
+              <a:defRPr sz="2000">
                 <a:solidFill>
                   <a:srgbClr val="B8C4B8"/>
                 </a:solidFill>
@@ -6427,9 +7313,9 @@
           <a:p>
             <a:pPr>
               <a:spcAft>
-                <a:spcPts val="800"/>
+                <a:spcPts val="600"/>
               </a:spcAft>
-              <a:defRPr sz="2200">
+              <a:defRPr sz="2000">
                 <a:solidFill>
                   <a:srgbClr val="B8C4B8"/>
                 </a:solidFill>
@@ -6441,16 +7327,83 @@
           </a:p>
         </p:txBody>
       </p:sp>
-      <p:sp>
-        <p:nvSpPr>
-          <p:cNvPr id="7" name="TextBox 6"/>
+      <p:pic>
+        <p:nvPicPr>
+          <p:cNvPr id="7" name="Picture 6" descr="unpainted-layout.jpg"/>
+          <p:cNvPicPr>
+            <a:picLocks noChangeAspect="1"/>
+          </p:cNvPicPr>
+          <p:nvPr/>
+        </p:nvPicPr>
+        <p:blipFill>
+          <a:blip r:embed="rId2"/>
+          <a:stretch>
+            <a:fillRect/>
+          </a:stretch>
+        </p:blipFill>
+        <p:spPr>
+          <a:xfrm>
+            <a:off x="6446520" y="1965960"/>
+            <a:ext cx="5120640" cy="4297680"/>
+          </a:xfrm>
+          <a:prstGeom prst="rect">
+            <a:avLst/>
+          </a:prstGeom>
+        </p:spPr>
+      </p:pic>
+      <p:sp>
+        <p:nvSpPr>
+          <p:cNvPr id="8" name="Rectangle 7"/>
+          <p:cNvSpPr/>
+          <p:nvPr/>
+        </p:nvSpPr>
+        <p:spPr>
+          <a:xfrm>
+            <a:off x="6446520" y="1965960"/>
+            <a:ext cx="5120640" cy="4297680"/>
+          </a:xfrm>
+          <a:prstGeom prst="rect">
+            <a:avLst/>
+          </a:prstGeom>
+          <a:noFill/>
+          <a:ln w="12700">
+            <a:solidFill>
+              <a:srgbClr val="365144"/>
+            </a:solidFill>
+          </a:ln>
+        </p:spPr>
+        <p:style>
+          <a:lnRef idx="1">
+            <a:schemeClr val="accent1"/>
+          </a:lnRef>
+          <a:fillRef idx="3">
+            <a:schemeClr val="accent1"/>
+          </a:fillRef>
+          <a:effectRef idx="2">
+            <a:schemeClr val="accent1"/>
+          </a:effectRef>
+          <a:fontRef idx="minor">
+            <a:schemeClr val="lt1"/>
+          </a:fontRef>
+        </p:style>
+        <p:txBody>
+          <a:bodyPr rtlCol="0" anchor="ctr"/>
+          <a:lstStyle/>
+          <a:p>
+            <a:pPr algn="ctr"/>
+          </a:p>
+        </p:txBody>
+      </p:sp>
+      <p:sp>
+        <p:nvSpPr>
+          <p:cNvPr id="9" name="TextBox 8"/>
           <p:cNvSpPr txBox="1"/>
           <p:nvPr/>
         </p:nvSpPr>
         <p:spPr>
           <a:xfrm>
-            <a:off x="640080" y="6355080"/>
-            <a:ext cx="10881360" cy="274320"/>
+            <a:off x="640080" y="6382512"/>
+            <a:ext cx="10881360" cy="228600"/>
           </a:xfrm>
           <a:prstGeom prst="rect">
             <a:avLst/>
@@ -6464,10 +7417,11 @@
           <a:lstStyle/>
           <a:p>
             <a:pPr algn="ctr">
-              <a:defRPr sz="1000">
+              <a:defRPr sz="1000" b="0">
                 <a:solidFill>
                   <a:srgbClr val="B8C4B8"/>
                 </a:solidFill>
+                <a:latin typeface="Trebuchet MS"/>
               </a:defRPr>
             </a:pPr>
             <a:r>
@@ -6554,7 +7508,7 @@
         <p:spPr>
           <a:xfrm>
             <a:off x="640080" y="502920"/>
-            <a:ext cx="2011680" cy="320040"/>
+            <a:ext cx="2103120" cy="274320"/>
           </a:xfrm>
           <a:prstGeom prst="rect">
             <a:avLst/>
@@ -6572,6 +7526,7 @@
                 <a:solidFill>
                   <a:srgbClr val="D89B3D"/>
                 </a:solidFill>
+                <a:latin typeface="Trebuchet MS"/>
               </a:defRPr>
             </a:pPr>
             <a:r>
@@ -6588,8 +7543,8 @@
         </p:nvSpPr>
         <p:spPr>
           <a:xfrm>
-            <a:off x="640080" y="868680"/>
-            <a:ext cx="10881360" cy="1143000"/>
+            <a:off x="640080" y="841248"/>
+            <a:ext cx="10881360" cy="868680"/>
           </a:xfrm>
           <a:prstGeom prst="rect">
             <a:avLst/>
@@ -6603,7 +7558,7 @@
           <a:lstStyle/>
           <a:p>
             <a:pPr>
-              <a:defRPr sz="3800" b="1">
+              <a:defRPr sz="3400" b="1">
                 <a:solidFill>
                   <a:srgbClr val="F2F0E8"/>
                 </a:solidFill>
@@ -6624,8 +7579,8 @@
         </p:nvSpPr>
         <p:spPr>
           <a:xfrm>
-            <a:off x="640080" y="2240280"/>
-            <a:ext cx="10881360" cy="3886200"/>
+            <a:off x="640080" y="2057400"/>
+            <a:ext cx="10881360" cy="4069080"/>
           </a:xfrm>
           <a:prstGeom prst="roundRect">
             <a:avLst/>
@@ -6669,8 +7624,8 @@
         </p:nvSpPr>
         <p:spPr>
           <a:xfrm>
-            <a:off x="960120" y="2487168"/>
-            <a:ext cx="10241280" cy="3429000"/>
+            <a:off x="960120" y="2331720"/>
+            <a:ext cx="10241280" cy="3611880"/>
           </a:xfrm>
           <a:prstGeom prst="rect">
             <a:avLst/>
@@ -6687,7 +7642,7 @@
               <a:spcAft>
                 <a:spcPts val="800"/>
               </a:spcAft>
-              <a:defRPr sz="1800">
+              <a:defRPr sz="2000">
                 <a:solidFill>
                   <a:srgbClr val="F2F0E8"/>
                 </a:solidFill>
@@ -6702,7 +7657,7 @@
               <a:spcAft>
                 <a:spcPts val="800"/>
               </a:spcAft>
-              <a:defRPr sz="1800">
+              <a:defRPr sz="2000">
                 <a:solidFill>
                   <a:srgbClr val="B8C4B8"/>
                 </a:solidFill>
@@ -6717,7 +7672,7 @@
               <a:spcAft>
                 <a:spcPts val="800"/>
               </a:spcAft>
-              <a:defRPr sz="1800">
+              <a:defRPr sz="2000">
                 <a:solidFill>
                   <a:srgbClr val="B8C4B8"/>
                 </a:solidFill>
@@ -6732,7 +7687,7 @@
               <a:spcAft>
                 <a:spcPts val="800"/>
               </a:spcAft>
-              <a:defRPr sz="1800">
+              <a:defRPr sz="2000">
                 <a:solidFill>
                   <a:srgbClr val="B8C4B8"/>
                 </a:solidFill>
@@ -6747,7 +7702,7 @@
               <a:spcAft>
                 <a:spcPts val="800"/>
               </a:spcAft>
-              <a:defRPr sz="1800">
+              <a:defRPr sz="2000">
                 <a:solidFill>
                   <a:srgbClr val="B8C4B8"/>
                 </a:solidFill>
@@ -6767,8 +7722,8 @@
         </p:nvSpPr>
         <p:spPr>
           <a:xfrm>
-            <a:off x="640080" y="6355080"/>
-            <a:ext cx="10881360" cy="274320"/>
+            <a:off x="640080" y="6382512"/>
+            <a:ext cx="10881360" cy="228600"/>
           </a:xfrm>
           <a:prstGeom prst="rect">
             <a:avLst/>
@@ -6782,10 +7737,11 @@
           <a:lstStyle/>
           <a:p>
             <a:pPr algn="ctr">
-              <a:defRPr sz="1000">
+              <a:defRPr sz="1000" b="0">
                 <a:solidFill>
                   <a:srgbClr val="B8C4B8"/>
                 </a:solidFill>
+                <a:latin typeface="Trebuchet MS"/>
               </a:defRPr>
             </a:pPr>
             <a:r>
@@ -6872,7 +7828,7 @@
         <p:spPr>
           <a:xfrm>
             <a:off x="640080" y="502920"/>
-            <a:ext cx="2011680" cy="320040"/>
+            <a:ext cx="2103120" cy="274320"/>
           </a:xfrm>
           <a:prstGeom prst="rect">
             <a:avLst/>
@@ -6890,6 +7846,7 @@
                 <a:solidFill>
                   <a:srgbClr val="D89B3D"/>
                 </a:solidFill>
+                <a:latin typeface="Trebuchet MS"/>
               </a:defRPr>
             </a:pPr>
             <a:r>
@@ -6906,8 +7863,8 @@
         </p:nvSpPr>
         <p:spPr>
           <a:xfrm>
-            <a:off x="640080" y="868680"/>
-            <a:ext cx="10881360" cy="1143000"/>
+            <a:off x="640080" y="841248"/>
+            <a:ext cx="10881360" cy="868680"/>
           </a:xfrm>
           <a:prstGeom prst="rect">
             <a:avLst/>
@@ -6921,7 +7878,7 @@
           <a:lstStyle/>
           <a:p>
             <a:pPr>
-              <a:defRPr sz="3800" b="1">
+              <a:defRPr sz="3400" b="1">
                 <a:solidFill>
                   <a:srgbClr val="F2F0E8"/>
                 </a:solidFill>
@@ -6942,8 +7899,8 @@
         </p:nvSpPr>
         <p:spPr>
           <a:xfrm>
-            <a:off x="640080" y="2240280"/>
-            <a:ext cx="10881360" cy="3886200"/>
+            <a:off x="640080" y="1965960"/>
+            <a:ext cx="5577840" cy="4297680"/>
           </a:xfrm>
           <a:prstGeom prst="roundRect">
             <a:avLst/>
@@ -6987,8 +7944,8 @@
         </p:nvSpPr>
         <p:spPr>
           <a:xfrm>
-            <a:off x="960120" y="2487168"/>
-            <a:ext cx="10241280" cy="3429000"/>
+            <a:off x="960120" y="2240280"/>
+            <a:ext cx="4983480" cy="3703320"/>
           </a:xfrm>
           <a:prstGeom prst="rect">
             <a:avLst/>
@@ -7003,120 +7960,172 @@
           <a:p>
             <a:pPr>
               <a:spcAft>
-                <a:spcPts val="800"/>
+                <a:spcPts val="600"/>
               </a:spcAft>
-              <a:defRPr sz="1800">
+              <a:defRPr sz="1700">
                 <a:solidFill>
                   <a:srgbClr val="F2F0E8"/>
                 </a:solidFill>
               </a:defRPr>
             </a:pPr>
             <a:r>
-              <a:t>• Air chamber</a:t>
+              <a:t>• Black pressure chamber stores compressed air.</a:t>
             </a:r>
           </a:p>
           <a:p>
             <a:pPr>
               <a:spcAft>
-                <a:spcPts val="800"/>
+                <a:spcPts val="600"/>
               </a:spcAft>
-              <a:defRPr sz="1800">
+              <a:defRPr sz="1700">
                 <a:solidFill>
                   <a:srgbClr val="B8C4B8"/>
                 </a:solidFill>
               </a:defRPr>
             </a:pPr>
             <a:r>
-              <a:t>• Barrel or launch tube</a:t>
+              <a:t>• Pressure gauge confirms operating state.</a:t>
             </a:r>
           </a:p>
           <a:p>
             <a:pPr>
               <a:spcAft>
-                <a:spcPts val="800"/>
+                <a:spcPts val="600"/>
               </a:spcAft>
-              <a:defRPr sz="1800">
+              <a:defRPr sz="1700">
                 <a:solidFill>
                   <a:srgbClr val="B8C4B8"/>
                 </a:solidFill>
               </a:defRPr>
             </a:pPr>
             <a:r>
-              <a:t>• Pressure gauge</a:t>
+              <a:t>• Blue valve hardware controls the pressure path.</a:t>
             </a:r>
           </a:p>
           <a:p>
             <a:pPr>
               <a:spcAft>
-                <a:spcPts val="800"/>
+                <a:spcPts val="600"/>
               </a:spcAft>
-              <a:defRPr sz="1800">
+              <a:defRPr sz="1700">
                 <a:solidFill>
                   <a:srgbClr val="B8C4B8"/>
                 </a:solidFill>
               </a:defRPr>
             </a:pPr>
             <a:r>
-              <a:t>• Fill valve</a:t>
+              <a:t>• Yellow release handle operates the launch.</a:t>
             </a:r>
           </a:p>
           <a:p>
             <a:pPr>
               <a:spcAft>
-                <a:spcPts val="800"/>
+                <a:spcPts val="600"/>
               </a:spcAft>
-              <a:defRPr sz="1800">
+              <a:defRPr sz="1700">
                 <a:solidFill>
                   <a:srgbClr val="B8C4B8"/>
                 </a:solidFill>
               </a:defRPr>
             </a:pPr>
             <a:r>
-              <a:t>• Release valve or trigger</a:t>
+              <a:t>• Green/yellow launch tube guides the payload.</a:t>
             </a:r>
           </a:p>
           <a:p>
             <a:pPr>
               <a:spcAft>
-                <a:spcPts val="800"/>
+                <a:spcPts val="600"/>
               </a:spcAft>
-              <a:defRPr sz="1800">
+              <a:defRPr sz="1700">
                 <a:solidFill>
                   <a:srgbClr val="B8C4B8"/>
                 </a:solidFill>
               </a:defRPr>
             </a:pPr>
             <a:r>
-              <a:t>• Base or support frame</a:t>
-            </a:r>
-          </a:p>
-          <a:p>
-            <a:pPr>
-              <a:spcAft>
-                <a:spcPts val="800"/>
-              </a:spcAft>
-              <a:defRPr sz="1800">
-                <a:solidFill>
-                  <a:srgbClr val="B8C4B8"/>
-                </a:solidFill>
-              </a:defRPr>
-            </a:pPr>
-            <a:r>
-              <a:t>• Safety labels and operating steps</a:t>
-            </a:r>
-          </a:p>
-        </p:txBody>
-      </p:sp>
-      <p:sp>
-        <p:nvSpPr>
-          <p:cNvPr id="7" name="TextBox 6"/>
+              <a:t>• Brackets keep the assemblies aligned.</a:t>
+            </a:r>
+          </a:p>
+        </p:txBody>
+      </p:sp>
+      <p:pic>
+        <p:nvPicPr>
+          <p:cNvPr id="7" name="Picture 6" descr="prototype-overview-painted.jpg"/>
+          <p:cNvPicPr>
+            <a:picLocks noChangeAspect="1"/>
+          </p:cNvPicPr>
+          <p:nvPr/>
+        </p:nvPicPr>
+        <p:blipFill>
+          <a:blip r:embed="rId2"/>
+          <a:stretch>
+            <a:fillRect/>
+          </a:stretch>
+        </p:blipFill>
+        <p:spPr>
+          <a:xfrm>
+            <a:off x="6446520" y="1965960"/>
+            <a:ext cx="5120640" cy="4297680"/>
+          </a:xfrm>
+          <a:prstGeom prst="rect">
+            <a:avLst/>
+          </a:prstGeom>
+        </p:spPr>
+      </p:pic>
+      <p:sp>
+        <p:nvSpPr>
+          <p:cNvPr id="8" name="Rectangle 7"/>
+          <p:cNvSpPr/>
+          <p:nvPr/>
+        </p:nvSpPr>
+        <p:spPr>
+          <a:xfrm>
+            <a:off x="6446520" y="1965960"/>
+            <a:ext cx="5120640" cy="4297680"/>
+          </a:xfrm>
+          <a:prstGeom prst="rect">
+            <a:avLst/>
+          </a:prstGeom>
+          <a:noFill/>
+          <a:ln w="12700">
+            <a:solidFill>
+              <a:srgbClr val="365144"/>
+            </a:solidFill>
+          </a:ln>
+        </p:spPr>
+        <p:style>
+          <a:lnRef idx="1">
+            <a:schemeClr val="accent1"/>
+          </a:lnRef>
+          <a:fillRef idx="3">
+            <a:schemeClr val="accent1"/>
+          </a:fillRef>
+          <a:effectRef idx="2">
+            <a:schemeClr val="accent1"/>
+          </a:effectRef>
+          <a:fontRef idx="minor">
+            <a:schemeClr val="lt1"/>
+          </a:fontRef>
+        </p:style>
+        <p:txBody>
+          <a:bodyPr rtlCol="0" anchor="ctr"/>
+          <a:lstStyle/>
+          <a:p>
+            <a:pPr algn="ctr"/>
+          </a:p>
+        </p:txBody>
+      </p:sp>
+      <p:sp>
+        <p:nvSpPr>
+          <p:cNvPr id="9" name="TextBox 8"/>
           <p:cNvSpPr txBox="1"/>
           <p:nvPr/>
         </p:nvSpPr>
         <p:spPr>
           <a:xfrm>
-            <a:off x="640080" y="6355080"/>
-            <a:ext cx="10881360" cy="274320"/>
+            <a:off x="640080" y="6382512"/>
+            <a:ext cx="10881360" cy="228600"/>
           </a:xfrm>
           <a:prstGeom prst="rect">
             <a:avLst/>
@@ -7130,10 +8139,11 @@
           <a:lstStyle/>
           <a:p>
             <a:pPr algn="ctr">
-              <a:defRPr sz="1000">
+              <a:defRPr sz="1000" b="0">
                 <a:solidFill>
                   <a:srgbClr val="B8C4B8"/>
                 </a:solidFill>
+                <a:latin typeface="Trebuchet MS"/>
               </a:defRPr>
             </a:pPr>
             <a:r>
@@ -7220,7 +8230,7 @@
         <p:spPr>
           <a:xfrm>
             <a:off x="640080" y="502920"/>
-            <a:ext cx="2011680" cy="320040"/>
+            <a:ext cx="2103120" cy="274320"/>
           </a:xfrm>
           <a:prstGeom prst="rect">
             <a:avLst/>
@@ -7238,6 +8248,7 @@
                 <a:solidFill>
                   <a:srgbClr val="D89B3D"/>
                 </a:solidFill>
+                <a:latin typeface="Trebuchet MS"/>
               </a:defRPr>
             </a:pPr>
             <a:r>
@@ -7254,8 +8265,8 @@
         </p:nvSpPr>
         <p:spPr>
           <a:xfrm>
-            <a:off x="640080" y="868680"/>
-            <a:ext cx="10881360" cy="1143000"/>
+            <a:off x="640080" y="841248"/>
+            <a:ext cx="10881360" cy="868680"/>
           </a:xfrm>
           <a:prstGeom prst="rect">
             <a:avLst/>
@@ -7269,7 +8280,7 @@
           <a:lstStyle/>
           <a:p>
             <a:pPr>
-              <a:defRPr sz="3800" b="1">
+              <a:defRPr sz="3400" b="1">
                 <a:solidFill>
                   <a:srgbClr val="F2F0E8"/>
                 </a:solidFill>
@@ -7277,7 +8288,7 @@
               </a:defRPr>
             </a:pPr>
             <a:r>
-              <a:t>STEM Principles</a:t>
+              <a:t>Pressure and Valve System</a:t>
             </a:r>
           </a:p>
         </p:txBody>
@@ -7290,8 +8301,8 @@
         </p:nvSpPr>
         <p:spPr>
           <a:xfrm>
-            <a:off x="640080" y="2240280"/>
-            <a:ext cx="10881360" cy="3886200"/>
+            <a:off x="640080" y="1965960"/>
+            <a:ext cx="5577840" cy="4297680"/>
           </a:xfrm>
           <a:prstGeom prst="roundRect">
             <a:avLst/>
@@ -7335,8 +8346,8 @@
         </p:nvSpPr>
         <p:spPr>
           <a:xfrm>
-            <a:off x="960120" y="2487168"/>
-            <a:ext cx="10241280" cy="3429000"/>
+            <a:off x="960120" y="2240280"/>
+            <a:ext cx="4983480" cy="3703320"/>
           </a:xfrm>
           <a:prstGeom prst="rect">
             <a:avLst/>
@@ -7351,90 +8362,142 @@
           <a:p>
             <a:pPr>
               <a:spcAft>
-                <a:spcPts val="800"/>
+                <a:spcPts val="600"/>
               </a:spcAft>
-              <a:defRPr sz="1800">
+              <a:defRPr sz="2000">
                 <a:solidFill>
                   <a:srgbClr val="F2F0E8"/>
                 </a:solidFill>
               </a:defRPr>
             </a:pPr>
             <a:r>
-              <a:t>• Pressure creates force: F = P x A.</a:t>
+              <a:t>• Gauge gives the operator a visible pressure reading.</a:t>
             </a:r>
           </a:p>
           <a:p>
             <a:pPr>
               <a:spcAft>
-                <a:spcPts val="800"/>
+                <a:spcPts val="600"/>
               </a:spcAft>
-              <a:defRPr sz="1800">
+              <a:defRPr sz="2000">
                 <a:solidFill>
                   <a:srgbClr val="B8C4B8"/>
                 </a:solidFill>
               </a:defRPr>
             </a:pPr>
             <a:r>
-              <a:t>• Launch angle affects range.</a:t>
+              <a:t>• Valve path controls fill, release, and reset.</a:t>
             </a:r>
           </a:p>
           <a:p>
             <a:pPr>
               <a:spcAft>
-                <a:spcPts val="800"/>
+                <a:spcPts val="600"/>
               </a:spcAft>
-              <a:defRPr sz="1800">
+              <a:defRPr sz="2000">
                 <a:solidFill>
                   <a:srgbClr val="B8C4B8"/>
                 </a:solidFill>
               </a:defRPr>
             </a:pPr>
             <a:r>
-              <a:t>• Payload mass affects acceleration.</a:t>
+              <a:t>• Hardware needs leak checks before launch.</a:t>
             </a:r>
           </a:p>
           <a:p>
             <a:pPr>
               <a:spcAft>
-                <a:spcPts val="800"/>
+                <a:spcPts val="600"/>
               </a:spcAft>
-              <a:defRPr sz="1800">
+              <a:defRPr sz="2000">
                 <a:solidFill>
                   <a:srgbClr val="B8C4B8"/>
                 </a:solidFill>
               </a:defRPr>
             </a:pPr>
             <a:r>
-              <a:t>• Air leakage reduces repeatability.</a:t>
-            </a:r>
-          </a:p>
-          <a:p>
-            <a:pPr>
-              <a:spcAft>
-                <a:spcPts val="800"/>
-              </a:spcAft>
-              <a:defRPr sz="1800">
-                <a:solidFill>
-                  <a:srgbClr val="B8C4B8"/>
-                </a:solidFill>
-              </a:defRPr>
-            </a:pPr>
-            <a:r>
-              <a:t>• Safety factor limits operating pressure.</a:t>
-            </a:r>
-          </a:p>
-        </p:txBody>
-      </p:sp>
-      <p:sp>
-        <p:nvSpPr>
-          <p:cNvPr id="7" name="TextBox 6"/>
+              <a:t>• Pressure limits must come from the weakest rated part.</a:t>
+            </a:r>
+          </a:p>
+        </p:txBody>
+      </p:sp>
+      <p:pic>
+        <p:nvPicPr>
+          <p:cNvPr id="7" name="Picture 6" descr="pressure-gauge-valve.jpg"/>
+          <p:cNvPicPr>
+            <a:picLocks noChangeAspect="1"/>
+          </p:cNvPicPr>
+          <p:nvPr/>
+        </p:nvPicPr>
+        <p:blipFill>
+          <a:blip r:embed="rId2"/>
+          <a:stretch>
+            <a:fillRect/>
+          </a:stretch>
+        </p:blipFill>
+        <p:spPr>
+          <a:xfrm>
+            <a:off x="6446520" y="2194560"/>
+            <a:ext cx="5120640" cy="3840480"/>
+          </a:xfrm>
+          <a:prstGeom prst="rect">
+            <a:avLst/>
+          </a:prstGeom>
+        </p:spPr>
+      </p:pic>
+      <p:sp>
+        <p:nvSpPr>
+          <p:cNvPr id="8" name="Rectangle 7"/>
+          <p:cNvSpPr/>
+          <p:nvPr/>
+        </p:nvSpPr>
+        <p:spPr>
+          <a:xfrm>
+            <a:off x="6446520" y="1965960"/>
+            <a:ext cx="5120640" cy="4297680"/>
+          </a:xfrm>
+          <a:prstGeom prst="rect">
+            <a:avLst/>
+          </a:prstGeom>
+          <a:noFill/>
+          <a:ln w="12700">
+            <a:solidFill>
+              <a:srgbClr val="365144"/>
+            </a:solidFill>
+          </a:ln>
+        </p:spPr>
+        <p:style>
+          <a:lnRef idx="1">
+            <a:schemeClr val="accent1"/>
+          </a:lnRef>
+          <a:fillRef idx="3">
+            <a:schemeClr val="accent1"/>
+          </a:fillRef>
+          <a:effectRef idx="2">
+            <a:schemeClr val="accent1"/>
+          </a:effectRef>
+          <a:fontRef idx="minor">
+            <a:schemeClr val="lt1"/>
+          </a:fontRef>
+        </p:style>
+        <p:txBody>
+          <a:bodyPr rtlCol="0" anchor="ctr"/>
+          <a:lstStyle/>
+          <a:p>
+            <a:pPr algn="ctr"/>
+          </a:p>
+        </p:txBody>
+      </p:sp>
+      <p:sp>
+        <p:nvSpPr>
+          <p:cNvPr id="9" name="TextBox 8"/>
           <p:cNvSpPr txBox="1"/>
           <p:nvPr/>
         </p:nvSpPr>
         <p:spPr>
           <a:xfrm>
-            <a:off x="640080" y="6355080"/>
-            <a:ext cx="10881360" cy="274320"/>
+            <a:off x="640080" y="6382512"/>
+            <a:ext cx="10881360" cy="228600"/>
           </a:xfrm>
           <a:prstGeom prst="rect">
             <a:avLst/>
@@ -7448,10 +8511,11 @@
           <a:lstStyle/>
           <a:p>
             <a:pPr algn="ctr">
-              <a:defRPr sz="1000">
+              <a:defRPr sz="1000" b="0">
                 <a:solidFill>
                   <a:srgbClr val="B8C4B8"/>
                 </a:solidFill>
+                <a:latin typeface="Trebuchet MS"/>
               </a:defRPr>
             </a:pPr>
             <a:r>

</xml_diff>